<commit_message>
education(2026-04-09): regenerate 2 materials with unified format
Body 18pt, footer "藪医者の学び / 日付 / トピック", new A4 1-page cheatsheet DOCX (12mm margins, right-top QR), removed 研修医向け display labels. Source: ai-agent-team scripts/education_build.py.

Co-Authored-By: Claude Opus 4.6 (1M context) <noreply@anthropic.com>
</commit_message>
<xml_diff>
--- a/output/education/2026-04-09_who-systems-thinking-residents/who-systems-thinking-residents_slides_residents.pptx
+++ b/output/education/2026-04-09_who-systems-thinking-residents/who-systems-thinking-residents_slides_residents.pptx
@@ -3175,7 +3175,7 @@
         <p:spPr>
           <a:xfrm>
             <a:off x="457200" y="365760"/>
-            <a:ext cx="11430000" cy="822960"/>
+            <a:ext cx="11430000" cy="914400"/>
           </a:xfrm>
           <a:prstGeom prst="rect">
             <a:avLst/>
@@ -3190,7 +3190,7 @@
           <a:p>
             <a:pPr algn="l"/>
             <a:r>
-              <a:rPr sz="3000" b="1">
+              <a:rPr sz="3600" b="1">
                 <a:solidFill>
                   <a:srgbClr val="E89B3B"/>
                 </a:solidFill>
@@ -3209,8 +3209,8 @@
         </p:nvSpPr>
         <p:spPr>
           <a:xfrm>
-            <a:off x="457200" y="1143000"/>
-            <a:ext cx="11430000" cy="640080"/>
+            <a:off x="457200" y="1234440"/>
+            <a:ext cx="11430000" cy="731520"/>
           </a:xfrm>
           <a:prstGeom prst="rect">
             <a:avLst/>
@@ -3225,7 +3225,7 @@
           <a:p>
             <a:pPr algn="l"/>
             <a:r>
-              <a:rPr sz="1800" b="0">
+              <a:rPr sz="2000" b="0">
                 <a:solidFill>
                   <a:srgbClr val="F5F0E8"/>
                 </a:solidFill>
@@ -3244,8 +3244,8 @@
         </p:nvSpPr>
         <p:spPr>
           <a:xfrm>
-            <a:off x="548640" y="1828800"/>
-            <a:ext cx="10972800" cy="2743200"/>
+            <a:off x="457200" y="6492240"/>
+            <a:ext cx="9601200" cy="320040"/>
           </a:xfrm>
           <a:prstGeom prst="rect">
             <a:avLst/>
@@ -3260,13 +3260,13 @@
           <a:p>
             <a:pPr algn="l"/>
             <a:r>
-              <a:rPr sz="1400" b="0">
-                <a:solidFill>
-                  <a:srgbClr val="F5F0E8"/>
-                </a:solidFill>
-                <a:latin typeface="Yu Gothic"/>
-              </a:rPr>
-              <a:t>家庭医療科 勉強会 / 2026-04-09 / 20分</a:t>
+              <a:rPr sz="1000" b="0">
+                <a:solidFill>
+                  <a:srgbClr val="7A8A9A"/>
+                </a:solidFill>
+                <a:latin typeface="Yu Gothic"/>
+              </a:rPr>
+              <a:t>藪医者の学び / 2026-04-09 / WHOシステム思考</a:t>
             </a:r>
           </a:p>
         </p:txBody>
@@ -3279,7 +3279,7 @@
         </p:nvSpPr>
         <p:spPr>
           <a:xfrm>
-            <a:off x="11247120" y="6446520"/>
+            <a:off x="11247120" y="6492240"/>
             <a:ext cx="914400" cy="320040"/>
           </a:xfrm>
           <a:prstGeom prst="rect">
@@ -3295,55 +3295,20 @@
           <a:p>
             <a:pPr algn="r"/>
             <a:r>
-              <a:rPr sz="900" b="0">
+              <a:rPr sz="1000" b="0">
                 <a:solidFill>
                   <a:srgbClr val="7A8A9A"/>
                 </a:solidFill>
                 <a:latin typeface="Yu Gothic"/>
               </a:rPr>
               <a:t>1 / 28</a:t>
-            </a:r>
-          </a:p>
-        </p:txBody>
-      </p:sp>
-      <p:sp>
-        <p:nvSpPr>
-          <p:cNvPr id="7" name="TextBox 6"/>
-          <p:cNvSpPr txBox="1"/>
-          <p:nvPr/>
-        </p:nvSpPr>
-        <p:spPr>
-          <a:xfrm>
-            <a:off x="457200" y="6446520"/>
-            <a:ext cx="7315200" cy="320040"/>
-          </a:xfrm>
-          <a:prstGeom prst="rect">
-            <a:avLst/>
-          </a:prstGeom>
-          <a:noFill/>
-        </p:spPr>
-        <p:txBody>
-          <a:bodyPr wrap="square" lIns="45720" rIns="45720" tIns="27432" bIns="27432">
-            <a:spAutoFit/>
-          </a:bodyPr>
-          <a:lstStyle/>
-          <a:p>
-            <a:pPr algn="l"/>
-            <a:r>
-              <a:rPr sz="900" b="0">
-                <a:solidFill>
-                  <a:srgbClr val="7A8A9A"/>
-                </a:solidFill>
-                <a:latin typeface="Yu Gothic"/>
-              </a:rPr>
-              <a:t>家庭医療科 勉強会 / 2026-04-09</a:t>
             </a:r>
           </a:p>
         </p:txBody>
       </p:sp>
       <p:pic>
         <p:nvPicPr>
-          <p:cNvPr id="8" name="Picture 7" descr="image.png"/>
+          <p:cNvPr id="7" name="Picture 6" descr="image.png"/>
           <p:cNvPicPr>
             <a:picLocks noChangeAspect="1"/>
           </p:cNvPicPr>
@@ -3357,8 +3322,8 @@
         </p:blipFill>
         <p:spPr>
           <a:xfrm>
-            <a:off x="10424160" y="5212080"/>
-            <a:ext cx="1280160" cy="1280160"/>
+            <a:off x="10424160" y="5120640"/>
+            <a:ext cx="1371600" cy="1371600"/>
           </a:xfrm>
           <a:prstGeom prst="rect">
             <a:avLst/>
@@ -3367,13 +3332,13 @@
       </p:pic>
       <p:sp>
         <p:nvSpPr>
-          <p:cNvPr id="9" name="TextBox 8"/>
-          <p:cNvSpPr txBox="1"/>
-          <p:nvPr/>
-        </p:nvSpPr>
-        <p:spPr>
-          <a:xfrm>
-            <a:off x="10424160" y="4983480"/>
+          <p:cNvPr id="8" name="TextBox 7"/>
+          <p:cNvSpPr txBox="1"/>
+          <p:nvPr/>
+        </p:nvSpPr>
+        <p:spPr>
+          <a:xfrm>
+            <a:off x="10424160" y="4892040"/>
             <a:ext cx="1463040" cy="228600"/>
           </a:xfrm>
           <a:prstGeom prst="rect">
@@ -3389,7 +3354,7 @@
           <a:p>
             <a:pPr algn="l"/>
             <a:r>
-              <a:rPr sz="800" b="1">
+              <a:rPr sz="900" b="1">
                 <a:solidFill>
                   <a:srgbClr val="F5F0E8"/>
                 </a:solidFill>
@@ -3478,7 +3443,7 @@
         <p:spPr>
           <a:xfrm>
             <a:off x="457200" y="365760"/>
-            <a:ext cx="11430000" cy="822960"/>
+            <a:ext cx="11430000" cy="914400"/>
           </a:xfrm>
           <a:prstGeom prst="rect">
             <a:avLst/>
@@ -3493,7 +3458,7 @@
           <a:p>
             <a:pPr algn="l"/>
             <a:r>
-              <a:rPr sz="2600" b="1">
+              <a:rPr sz="3000" b="1">
                 <a:solidFill>
                   <a:srgbClr val="0D2B3E"/>
                 </a:solidFill>
@@ -3513,8 +3478,8 @@
           <p:nvPr/>
         </p:nvGraphicFramePr>
         <p:xfrm>
-          <a:off x="548640" y="1371600"/>
-          <a:ext cx="10972800" cy="2011680"/>
+          <a:off x="548640" y="1463040"/>
+          <a:ext cx="10972800" cy="2194560"/>
         </p:xfrm>
         <a:graphic>
           <a:graphicData uri="http://schemas.openxmlformats.org/drawingml/2006/table">
@@ -3527,7 +3492,7 @@
                 <a:gridCol w="3657600"/>
                 <a:gridCol w="3657600"/>
               </a:tblGrid>
-              <a:tr h="502920">
+              <a:tr h="548640">
                 <a:tc>
                   <a:txBody>
                     <a:bodyPr/>
@@ -3546,7 +3511,7 @@
                     <a:lstStyle/>
                     <a:p>
                       <a:r>
-                        <a:rPr sz="1200" b="1">
+                        <a:rPr sz="1400" b="1">
                           <a:solidFill>
                             <a:srgbClr val="F5F0E8"/>
                           </a:solidFill>
@@ -3568,7 +3533,7 @@
                     <a:lstStyle/>
                     <a:p>
                       <a:r>
-                        <a:rPr sz="1200" b="1">
+                        <a:rPr sz="1400" b="1">
                           <a:solidFill>
                             <a:srgbClr val="F5F0E8"/>
                           </a:solidFill>
@@ -3585,14 +3550,14 @@
                   </a:tcPr>
                 </a:tc>
               </a:tr>
-              <a:tr h="502920">
+              <a:tr h="548640">
                 <a:tc>
                   <a:txBody>
                     <a:bodyPr/>
                     <a:lstStyle/>
                     <a:p>
                       <a:r>
-                        <a:rPr sz="1200">
+                        <a:rPr sz="1400">
                           <a:solidFill>
                             <a:srgbClr val="1A1A2E"/>
                           </a:solidFill>
@@ -3614,7 +3579,7 @@
                     <a:lstStyle/>
                     <a:p>
                       <a:r>
-                        <a:rPr sz="1200">
+                        <a:rPr sz="1400">
                           <a:solidFill>
                             <a:srgbClr val="1A1A2E"/>
                           </a:solidFill>
@@ -3636,7 +3601,7 @@
                     <a:lstStyle/>
                     <a:p>
                       <a:r>
-                        <a:rPr sz="1200">
+                        <a:rPr sz="1400">
                           <a:solidFill>
                             <a:srgbClr val="1A1A2E"/>
                           </a:solidFill>
@@ -3653,14 +3618,14 @@
                   </a:tcPr>
                 </a:tc>
               </a:tr>
-              <a:tr h="502920">
+              <a:tr h="548640">
                 <a:tc>
                   <a:txBody>
                     <a:bodyPr/>
                     <a:lstStyle/>
                     <a:p>
                       <a:r>
-                        <a:rPr sz="1200">
+                        <a:rPr sz="1400">
                           <a:solidFill>
                             <a:srgbClr val="1A1A2E"/>
                           </a:solidFill>
@@ -3682,7 +3647,7 @@
                     <a:lstStyle/>
                     <a:p>
                       <a:r>
-                        <a:rPr sz="1200">
+                        <a:rPr sz="1400">
                           <a:solidFill>
                             <a:srgbClr val="1A1A2E"/>
                           </a:solidFill>
@@ -3704,7 +3669,7 @@
                     <a:lstStyle/>
                     <a:p>
                       <a:r>
-                        <a:rPr sz="1200">
+                        <a:rPr sz="1400">
                           <a:solidFill>
                             <a:srgbClr val="1A1A2E"/>
                           </a:solidFill>
@@ -3721,14 +3686,14 @@
                   </a:tcPr>
                 </a:tc>
               </a:tr>
-              <a:tr h="502920">
+              <a:tr h="548640">
                 <a:tc>
                   <a:txBody>
                     <a:bodyPr/>
                     <a:lstStyle/>
                     <a:p>
                       <a:r>
-                        <a:rPr sz="1200">
+                        <a:rPr sz="1400">
                           <a:solidFill>
                             <a:srgbClr val="1A1A2E"/>
                           </a:solidFill>
@@ -3750,7 +3715,7 @@
                     <a:lstStyle/>
                     <a:p>
                       <a:r>
-                        <a:rPr sz="1200">
+                        <a:rPr sz="1400">
                           <a:solidFill>
                             <a:srgbClr val="1A1A2E"/>
                           </a:solidFill>
@@ -3772,7 +3737,7 @@
                     <a:lstStyle/>
                     <a:p>
                       <a:r>
-                        <a:rPr sz="1200">
+                        <a:rPr sz="1400">
                           <a:solidFill>
                             <a:srgbClr val="1A1A2E"/>
                           </a:solidFill>
@@ -3801,7 +3766,7 @@
         </p:nvSpPr>
         <p:spPr>
           <a:xfrm>
-            <a:off x="548640" y="3657600"/>
+            <a:off x="548640" y="3931920"/>
             <a:ext cx="10972800" cy="1371600"/>
           </a:xfrm>
           <a:prstGeom prst="rect">
@@ -3817,7 +3782,7 @@
           <a:p>
             <a:pPr algn="l"/>
             <a:r>
-              <a:rPr sz="1400" b="0">
+              <a:rPr sz="1800" b="0">
                 <a:solidFill>
                   <a:srgbClr val="1A1A2E"/>
                 </a:solidFill>
@@ -3836,7 +3801,42 @@
         </p:nvSpPr>
         <p:spPr>
           <a:xfrm>
-            <a:off x="11247120" y="6446520"/>
+            <a:off x="457200" y="6492240"/>
+            <a:ext cx="9601200" cy="320040"/>
+          </a:xfrm>
+          <a:prstGeom prst="rect">
+            <a:avLst/>
+          </a:prstGeom>
+          <a:noFill/>
+        </p:spPr>
+        <p:txBody>
+          <a:bodyPr wrap="square" lIns="45720" rIns="45720" tIns="27432" bIns="27432">
+            <a:spAutoFit/>
+          </a:bodyPr>
+          <a:lstStyle/>
+          <a:p>
+            <a:pPr algn="l"/>
+            <a:r>
+              <a:rPr sz="1000" b="0">
+                <a:solidFill>
+                  <a:srgbClr val="7A8A9A"/>
+                </a:solidFill>
+                <a:latin typeface="Yu Gothic"/>
+              </a:rPr>
+              <a:t>藪医者の学び / 2026-04-09 / WHOシステム思考</a:t>
+            </a:r>
+          </a:p>
+        </p:txBody>
+      </p:sp>
+      <p:sp>
+        <p:nvSpPr>
+          <p:cNvPr id="7" name="TextBox 6"/>
+          <p:cNvSpPr txBox="1"/>
+          <p:nvPr/>
+        </p:nvSpPr>
+        <p:spPr>
+          <a:xfrm>
+            <a:off x="11247120" y="6492240"/>
             <a:ext cx="914400" cy="320040"/>
           </a:xfrm>
           <a:prstGeom prst="rect">
@@ -3852,48 +3852,13 @@
           <a:p>
             <a:pPr algn="r"/>
             <a:r>
-              <a:rPr sz="900" b="0">
+              <a:rPr sz="1000" b="0">
                 <a:solidFill>
                   <a:srgbClr val="7A8A9A"/>
                 </a:solidFill>
                 <a:latin typeface="Yu Gothic"/>
               </a:rPr>
               <a:t>10 / 28</a:t>
-            </a:r>
-          </a:p>
-        </p:txBody>
-      </p:sp>
-      <p:sp>
-        <p:nvSpPr>
-          <p:cNvPr id="7" name="TextBox 6"/>
-          <p:cNvSpPr txBox="1"/>
-          <p:nvPr/>
-        </p:nvSpPr>
-        <p:spPr>
-          <a:xfrm>
-            <a:off x="457200" y="6446520"/>
-            <a:ext cx="7315200" cy="320040"/>
-          </a:xfrm>
-          <a:prstGeom prst="rect">
-            <a:avLst/>
-          </a:prstGeom>
-          <a:noFill/>
-        </p:spPr>
-        <p:txBody>
-          <a:bodyPr wrap="square" lIns="45720" rIns="45720" tIns="27432" bIns="27432">
-            <a:spAutoFit/>
-          </a:bodyPr>
-          <a:lstStyle/>
-          <a:p>
-            <a:pPr algn="l"/>
-            <a:r>
-              <a:rPr sz="900" b="0">
-                <a:solidFill>
-                  <a:srgbClr val="7A8A9A"/>
-                </a:solidFill>
-                <a:latin typeface="Yu Gothic"/>
-              </a:rPr>
-              <a:t>家庭医療科 勉強会 / 2026-04-09</a:t>
             </a:r>
           </a:p>
         </p:txBody>
@@ -3976,7 +3941,7 @@
         <p:spPr>
           <a:xfrm>
             <a:off x="457200" y="365760"/>
-            <a:ext cx="11430000" cy="822960"/>
+            <a:ext cx="11430000" cy="914400"/>
           </a:xfrm>
           <a:prstGeom prst="rect">
             <a:avLst/>
@@ -3991,7 +3956,7 @@
           <a:p>
             <a:pPr algn="l"/>
             <a:r>
-              <a:rPr sz="2600" b="1">
+              <a:rPr sz="3000" b="1">
                 <a:solidFill>
                   <a:srgbClr val="0D2B3E"/>
                 </a:solidFill>
@@ -4010,8 +3975,8 @@
         </p:nvSpPr>
         <p:spPr>
           <a:xfrm>
-            <a:off x="548640" y="1371600"/>
-            <a:ext cx="10972800" cy="3200400"/>
+            <a:off x="548640" y="1463040"/>
+            <a:ext cx="10972800" cy="3566160"/>
           </a:xfrm>
           <a:prstGeom prst="rect">
             <a:avLst/>
@@ -4026,7 +3991,7 @@
           <a:p>
             <a:pPr algn="l"/>
             <a:r>
-              <a:rPr sz="1400" b="0">
+              <a:rPr sz="1800" b="0">
                 <a:solidFill>
                   <a:srgbClr val="1A1A2E"/>
                 </a:solidFill>
@@ -4036,7 +4001,7 @@
             </a:r>
             <a:br/>
             <a:r>
-              <a:rPr sz="1400" b="0">
+              <a:rPr sz="1800" b="0">
                 <a:solidFill>
                   <a:srgbClr val="1A1A2E"/>
                 </a:solidFill>
@@ -4055,8 +4020,8 @@
         </p:nvSpPr>
         <p:spPr>
           <a:xfrm>
-            <a:off x="548640" y="2743200"/>
-            <a:ext cx="10972800" cy="2286000"/>
+            <a:off x="548640" y="3108960"/>
+            <a:ext cx="10972800" cy="2377439"/>
           </a:xfrm>
           <a:prstGeom prst="rect">
             <a:avLst/>
@@ -4070,7 +4035,7 @@
           <a:lstStyle/>
           <a:p>
             <a:r>
-              <a:rPr sz="1400">
+              <a:rPr sz="1800">
                 <a:solidFill>
                   <a:srgbClr val="1A1A2E"/>
                 </a:solidFill>
@@ -4081,7 +4046,7 @@
           </a:p>
           <a:p>
             <a:r>
-              <a:rPr sz="1400">
+              <a:rPr sz="1800">
                 <a:solidFill>
                   <a:srgbClr val="1A1A2E"/>
                 </a:solidFill>
@@ -4100,7 +4065,42 @@
         </p:nvSpPr>
         <p:spPr>
           <a:xfrm>
-            <a:off x="11247120" y="6446520"/>
+            <a:off x="457200" y="6492240"/>
+            <a:ext cx="9601200" cy="320040"/>
+          </a:xfrm>
+          <a:prstGeom prst="rect">
+            <a:avLst/>
+          </a:prstGeom>
+          <a:noFill/>
+        </p:spPr>
+        <p:txBody>
+          <a:bodyPr wrap="square" lIns="45720" rIns="45720" tIns="27432" bIns="27432">
+            <a:spAutoFit/>
+          </a:bodyPr>
+          <a:lstStyle/>
+          <a:p>
+            <a:pPr algn="l"/>
+            <a:r>
+              <a:rPr sz="1000" b="0">
+                <a:solidFill>
+                  <a:srgbClr val="7A8A9A"/>
+                </a:solidFill>
+                <a:latin typeface="Yu Gothic"/>
+              </a:rPr>
+              <a:t>藪医者の学び / 2026-04-09 / WHOシステム思考</a:t>
+            </a:r>
+          </a:p>
+        </p:txBody>
+      </p:sp>
+      <p:sp>
+        <p:nvSpPr>
+          <p:cNvPr id="7" name="TextBox 6"/>
+          <p:cNvSpPr txBox="1"/>
+          <p:nvPr/>
+        </p:nvSpPr>
+        <p:spPr>
+          <a:xfrm>
+            <a:off x="11247120" y="6492240"/>
             <a:ext cx="914400" cy="320040"/>
           </a:xfrm>
           <a:prstGeom prst="rect">
@@ -4116,48 +4116,13 @@
           <a:p>
             <a:pPr algn="r"/>
             <a:r>
-              <a:rPr sz="900" b="0">
+              <a:rPr sz="1000" b="0">
                 <a:solidFill>
                   <a:srgbClr val="7A8A9A"/>
                 </a:solidFill>
                 <a:latin typeface="Yu Gothic"/>
               </a:rPr>
               <a:t>11 / 28</a:t>
-            </a:r>
-          </a:p>
-        </p:txBody>
-      </p:sp>
-      <p:sp>
-        <p:nvSpPr>
-          <p:cNvPr id="7" name="TextBox 6"/>
-          <p:cNvSpPr txBox="1"/>
-          <p:nvPr/>
-        </p:nvSpPr>
-        <p:spPr>
-          <a:xfrm>
-            <a:off x="457200" y="6446520"/>
-            <a:ext cx="7315200" cy="320040"/>
-          </a:xfrm>
-          <a:prstGeom prst="rect">
-            <a:avLst/>
-          </a:prstGeom>
-          <a:noFill/>
-        </p:spPr>
-        <p:txBody>
-          <a:bodyPr wrap="square" lIns="45720" rIns="45720" tIns="27432" bIns="27432">
-            <a:spAutoFit/>
-          </a:bodyPr>
-          <a:lstStyle/>
-          <a:p>
-            <a:pPr algn="l"/>
-            <a:r>
-              <a:rPr sz="900" b="0">
-                <a:solidFill>
-                  <a:srgbClr val="7A8A9A"/>
-                </a:solidFill>
-                <a:latin typeface="Yu Gothic"/>
-              </a:rPr>
-              <a:t>家庭医療科 勉強会 / 2026-04-09</a:t>
             </a:r>
           </a:p>
         </p:txBody>
@@ -4240,7 +4205,7 @@
         <p:spPr>
           <a:xfrm>
             <a:off x="457200" y="365760"/>
-            <a:ext cx="11430000" cy="822960"/>
+            <a:ext cx="11430000" cy="914400"/>
           </a:xfrm>
           <a:prstGeom prst="rect">
             <a:avLst/>
@@ -4255,7 +4220,7 @@
           <a:p>
             <a:pPr algn="l"/>
             <a:r>
-              <a:rPr sz="2600" b="1">
+              <a:rPr sz="3000" b="1">
                 <a:solidFill>
                   <a:srgbClr val="0D2B3E"/>
                 </a:solidFill>
@@ -4274,8 +4239,8 @@
         </p:nvSpPr>
         <p:spPr>
           <a:xfrm>
-            <a:off x="548640" y="1371600"/>
-            <a:ext cx="10972800" cy="3200400"/>
+            <a:off x="548640" y="1463040"/>
+            <a:ext cx="10972800" cy="3566160"/>
           </a:xfrm>
           <a:prstGeom prst="rect">
             <a:avLst/>
@@ -4290,7 +4255,7 @@
           <a:p>
             <a:pPr algn="l"/>
             <a:r>
-              <a:rPr sz="1400" b="0">
+              <a:rPr sz="1800" b="0">
                 <a:solidFill>
                   <a:srgbClr val="1A1A2E"/>
                 </a:solidFill>
@@ -4300,7 +4265,7 @@
             </a:r>
             <a:br/>
             <a:r>
-              <a:rPr sz="1400" b="0">
+              <a:rPr sz="1800" b="0">
                 <a:solidFill>
                   <a:srgbClr val="1A1A2E"/>
                 </a:solidFill>
@@ -4310,7 +4275,7 @@
             </a:r>
             <a:br/>
             <a:r>
-              <a:rPr sz="1400" b="0">
+              <a:rPr sz="1800" b="0">
                 <a:solidFill>
                   <a:srgbClr val="1A1A2E"/>
                 </a:solidFill>
@@ -4329,8 +4294,8 @@
         </p:nvSpPr>
         <p:spPr>
           <a:xfrm>
-            <a:off x="548640" y="2743200"/>
-            <a:ext cx="10972800" cy="2286000"/>
+            <a:off x="548640" y="3108960"/>
+            <a:ext cx="10972800" cy="2377439"/>
           </a:xfrm>
           <a:prstGeom prst="rect">
             <a:avLst/>
@@ -4344,7 +4309,7 @@
           <a:lstStyle/>
           <a:p>
             <a:r>
-              <a:rPr sz="1400">
+              <a:rPr sz="1800">
                 <a:solidFill>
                   <a:srgbClr val="1A1A2E"/>
                 </a:solidFill>
@@ -4355,7 +4320,7 @@
           </a:p>
           <a:p>
             <a:r>
-              <a:rPr sz="1400">
+              <a:rPr sz="1800">
                 <a:solidFill>
                   <a:srgbClr val="1A1A2E"/>
                 </a:solidFill>
@@ -4374,7 +4339,42 @@
         </p:nvSpPr>
         <p:spPr>
           <a:xfrm>
-            <a:off x="11247120" y="6446520"/>
+            <a:off x="457200" y="6492240"/>
+            <a:ext cx="9601200" cy="320040"/>
+          </a:xfrm>
+          <a:prstGeom prst="rect">
+            <a:avLst/>
+          </a:prstGeom>
+          <a:noFill/>
+        </p:spPr>
+        <p:txBody>
+          <a:bodyPr wrap="square" lIns="45720" rIns="45720" tIns="27432" bIns="27432">
+            <a:spAutoFit/>
+          </a:bodyPr>
+          <a:lstStyle/>
+          <a:p>
+            <a:pPr algn="l"/>
+            <a:r>
+              <a:rPr sz="1000" b="0">
+                <a:solidFill>
+                  <a:srgbClr val="7A8A9A"/>
+                </a:solidFill>
+                <a:latin typeface="Yu Gothic"/>
+              </a:rPr>
+              <a:t>藪医者の学び / 2026-04-09 / WHOシステム思考</a:t>
+            </a:r>
+          </a:p>
+        </p:txBody>
+      </p:sp>
+      <p:sp>
+        <p:nvSpPr>
+          <p:cNvPr id="7" name="TextBox 6"/>
+          <p:cNvSpPr txBox="1"/>
+          <p:nvPr/>
+        </p:nvSpPr>
+        <p:spPr>
+          <a:xfrm>
+            <a:off x="11247120" y="6492240"/>
             <a:ext cx="914400" cy="320040"/>
           </a:xfrm>
           <a:prstGeom prst="rect">
@@ -4390,48 +4390,13 @@
           <a:p>
             <a:pPr algn="r"/>
             <a:r>
-              <a:rPr sz="900" b="0">
+              <a:rPr sz="1000" b="0">
                 <a:solidFill>
                   <a:srgbClr val="7A8A9A"/>
                 </a:solidFill>
                 <a:latin typeface="Yu Gothic"/>
               </a:rPr>
               <a:t>12 / 28</a:t>
-            </a:r>
-          </a:p>
-        </p:txBody>
-      </p:sp>
-      <p:sp>
-        <p:nvSpPr>
-          <p:cNvPr id="7" name="TextBox 6"/>
-          <p:cNvSpPr txBox="1"/>
-          <p:nvPr/>
-        </p:nvSpPr>
-        <p:spPr>
-          <a:xfrm>
-            <a:off x="457200" y="6446520"/>
-            <a:ext cx="7315200" cy="320040"/>
-          </a:xfrm>
-          <a:prstGeom prst="rect">
-            <a:avLst/>
-          </a:prstGeom>
-          <a:noFill/>
-        </p:spPr>
-        <p:txBody>
-          <a:bodyPr wrap="square" lIns="45720" rIns="45720" tIns="27432" bIns="27432">
-            <a:spAutoFit/>
-          </a:bodyPr>
-          <a:lstStyle/>
-          <a:p>
-            <a:pPr algn="l"/>
-            <a:r>
-              <a:rPr sz="900" b="0">
-                <a:solidFill>
-                  <a:srgbClr val="7A8A9A"/>
-                </a:solidFill>
-                <a:latin typeface="Yu Gothic"/>
-              </a:rPr>
-              <a:t>家庭医療科 勉強会 / 2026-04-09</a:t>
             </a:r>
           </a:p>
         </p:txBody>
@@ -4514,7 +4479,7 @@
         <p:spPr>
           <a:xfrm>
             <a:off x="457200" y="365760"/>
-            <a:ext cx="11430000" cy="822960"/>
+            <a:ext cx="11430000" cy="914400"/>
           </a:xfrm>
           <a:prstGeom prst="rect">
             <a:avLst/>
@@ -4529,7 +4494,7 @@
           <a:p>
             <a:pPr algn="l"/>
             <a:r>
-              <a:rPr sz="2600" b="1">
+              <a:rPr sz="3000" b="1">
                 <a:solidFill>
                   <a:srgbClr val="0D2B3E"/>
                 </a:solidFill>
@@ -4548,8 +4513,8 @@
         </p:nvSpPr>
         <p:spPr>
           <a:xfrm>
-            <a:off x="548640" y="1371600"/>
-            <a:ext cx="10972800" cy="3200400"/>
+            <a:off x="548640" y="1463040"/>
+            <a:ext cx="10972800" cy="3566160"/>
           </a:xfrm>
           <a:prstGeom prst="rect">
             <a:avLst/>
@@ -4564,7 +4529,7 @@
           <a:p>
             <a:pPr algn="l"/>
             <a:r>
-              <a:rPr sz="1400" b="0">
+              <a:rPr sz="1800" b="0">
                 <a:solidFill>
                   <a:srgbClr val="1A1A2E"/>
                 </a:solidFill>
@@ -4574,7 +4539,7 @@
             </a:r>
             <a:br/>
             <a:r>
-              <a:rPr sz="1400" b="0">
+              <a:rPr sz="1800" b="0">
                 <a:solidFill>
                   <a:srgbClr val="1A1A2E"/>
                 </a:solidFill>
@@ -4593,8 +4558,8 @@
         </p:nvSpPr>
         <p:spPr>
           <a:xfrm>
-            <a:off x="548640" y="2743200"/>
-            <a:ext cx="10972800" cy="2286000"/>
+            <a:off x="548640" y="3108960"/>
+            <a:ext cx="10972800" cy="2377439"/>
           </a:xfrm>
           <a:prstGeom prst="rect">
             <a:avLst/>
@@ -4608,7 +4573,7 @@
           <a:lstStyle/>
           <a:p>
             <a:r>
-              <a:rPr sz="1400">
+              <a:rPr sz="1800">
                 <a:solidFill>
                   <a:srgbClr val="1A1A2E"/>
                 </a:solidFill>
@@ -4619,7 +4584,7 @@
           </a:p>
           <a:p>
             <a:r>
-              <a:rPr sz="1400">
+              <a:rPr sz="1800">
                 <a:solidFill>
                   <a:srgbClr val="1A1A2E"/>
                 </a:solidFill>
@@ -4638,7 +4603,42 @@
         </p:nvSpPr>
         <p:spPr>
           <a:xfrm>
-            <a:off x="11247120" y="6446520"/>
+            <a:off x="457200" y="6492240"/>
+            <a:ext cx="9601200" cy="320040"/>
+          </a:xfrm>
+          <a:prstGeom prst="rect">
+            <a:avLst/>
+          </a:prstGeom>
+          <a:noFill/>
+        </p:spPr>
+        <p:txBody>
+          <a:bodyPr wrap="square" lIns="45720" rIns="45720" tIns="27432" bIns="27432">
+            <a:spAutoFit/>
+          </a:bodyPr>
+          <a:lstStyle/>
+          <a:p>
+            <a:pPr algn="l"/>
+            <a:r>
+              <a:rPr sz="1000" b="0">
+                <a:solidFill>
+                  <a:srgbClr val="7A8A9A"/>
+                </a:solidFill>
+                <a:latin typeface="Yu Gothic"/>
+              </a:rPr>
+              <a:t>藪医者の学び / 2026-04-09 / WHOシステム思考</a:t>
+            </a:r>
+          </a:p>
+        </p:txBody>
+      </p:sp>
+      <p:sp>
+        <p:nvSpPr>
+          <p:cNvPr id="7" name="TextBox 6"/>
+          <p:cNvSpPr txBox="1"/>
+          <p:nvPr/>
+        </p:nvSpPr>
+        <p:spPr>
+          <a:xfrm>
+            <a:off x="11247120" y="6492240"/>
             <a:ext cx="914400" cy="320040"/>
           </a:xfrm>
           <a:prstGeom prst="rect">
@@ -4654,48 +4654,13 @@
           <a:p>
             <a:pPr algn="r"/>
             <a:r>
-              <a:rPr sz="900" b="0">
+              <a:rPr sz="1000" b="0">
                 <a:solidFill>
                   <a:srgbClr val="7A8A9A"/>
                 </a:solidFill>
                 <a:latin typeface="Yu Gothic"/>
               </a:rPr>
               <a:t>13 / 28</a:t>
-            </a:r>
-          </a:p>
-        </p:txBody>
-      </p:sp>
-      <p:sp>
-        <p:nvSpPr>
-          <p:cNvPr id="7" name="TextBox 6"/>
-          <p:cNvSpPr txBox="1"/>
-          <p:nvPr/>
-        </p:nvSpPr>
-        <p:spPr>
-          <a:xfrm>
-            <a:off x="457200" y="6446520"/>
-            <a:ext cx="7315200" cy="320040"/>
-          </a:xfrm>
-          <a:prstGeom prst="rect">
-            <a:avLst/>
-          </a:prstGeom>
-          <a:noFill/>
-        </p:spPr>
-        <p:txBody>
-          <a:bodyPr wrap="square" lIns="45720" rIns="45720" tIns="27432" bIns="27432">
-            <a:spAutoFit/>
-          </a:bodyPr>
-          <a:lstStyle/>
-          <a:p>
-            <a:pPr algn="l"/>
-            <a:r>
-              <a:rPr sz="900" b="0">
-                <a:solidFill>
-                  <a:srgbClr val="7A8A9A"/>
-                </a:solidFill>
-                <a:latin typeface="Yu Gothic"/>
-              </a:rPr>
-              <a:t>家庭医療科 勉強会 / 2026-04-09</a:t>
             </a:r>
           </a:p>
         </p:txBody>
@@ -4778,7 +4743,7 @@
         <p:spPr>
           <a:xfrm>
             <a:off x="457200" y="365760"/>
-            <a:ext cx="11430000" cy="822960"/>
+            <a:ext cx="11430000" cy="914400"/>
           </a:xfrm>
           <a:prstGeom prst="rect">
             <a:avLst/>
@@ -4793,7 +4758,7 @@
           <a:p>
             <a:pPr algn="l"/>
             <a:r>
-              <a:rPr sz="2600" b="1">
+              <a:rPr sz="3000" b="1">
                 <a:solidFill>
                   <a:srgbClr val="0D2B3E"/>
                 </a:solidFill>
@@ -4813,8 +4778,8 @@
           <p:nvPr/>
         </p:nvGraphicFramePr>
         <p:xfrm>
-          <a:off x="548640" y="1371600"/>
-          <a:ext cx="10972800" cy="2011680"/>
+          <a:off x="548640" y="1463040"/>
+          <a:ext cx="10972800" cy="2194560"/>
         </p:xfrm>
         <a:graphic>
           <a:graphicData uri="http://schemas.openxmlformats.org/drawingml/2006/table">
@@ -4826,14 +4791,14 @@
                 <a:gridCol w="5486400"/>
                 <a:gridCol w="5486400"/>
               </a:tblGrid>
-              <a:tr h="502920">
+              <a:tr h="548640">
                 <a:tc>
                   <a:txBody>
                     <a:bodyPr/>
                     <a:lstStyle/>
                     <a:p>
                       <a:r>
-                        <a:rPr sz="1200" b="1">
+                        <a:rPr sz="1400" b="1">
                           <a:solidFill>
                             <a:srgbClr val="F5F0E8"/>
                           </a:solidFill>
@@ -4855,7 +4820,7 @@
                     <a:lstStyle/>
                     <a:p>
                       <a:r>
-                        <a:rPr sz="1200" b="1">
+                        <a:rPr sz="1400" b="1">
                           <a:solidFill>
                             <a:srgbClr val="F5F0E8"/>
                           </a:solidFill>
@@ -4872,14 +4837,14 @@
                   </a:tcPr>
                 </a:tc>
               </a:tr>
-              <a:tr h="502920">
+              <a:tr h="548640">
                 <a:tc>
                   <a:txBody>
                     <a:bodyPr/>
                     <a:lstStyle/>
                     <a:p>
                       <a:r>
-                        <a:rPr sz="1200">
+                        <a:rPr sz="1400">
                           <a:solidFill>
                             <a:srgbClr val="1A1A2E"/>
                           </a:solidFill>
@@ -4901,7 +4866,7 @@
                     <a:lstStyle/>
                     <a:p>
                       <a:r>
-                        <a:rPr sz="1200">
+                        <a:rPr sz="1400">
                           <a:solidFill>
                             <a:srgbClr val="1A1A2E"/>
                           </a:solidFill>
@@ -4918,14 +4883,14 @@
                   </a:tcPr>
                 </a:tc>
               </a:tr>
-              <a:tr h="502920">
+              <a:tr h="548640">
                 <a:tc>
                   <a:txBody>
                     <a:bodyPr/>
                     <a:lstStyle/>
                     <a:p>
                       <a:r>
-                        <a:rPr sz="1200">
+                        <a:rPr sz="1400">
                           <a:solidFill>
                             <a:srgbClr val="1A1A2E"/>
                           </a:solidFill>
@@ -4947,7 +4912,7 @@
                     <a:lstStyle/>
                     <a:p>
                       <a:r>
-                        <a:rPr sz="1200">
+                        <a:rPr sz="1400">
                           <a:solidFill>
                             <a:srgbClr val="1A1A2E"/>
                           </a:solidFill>
@@ -4964,14 +4929,14 @@
                   </a:tcPr>
                 </a:tc>
               </a:tr>
-              <a:tr h="502920">
+              <a:tr h="548640">
                 <a:tc>
                   <a:txBody>
                     <a:bodyPr/>
                     <a:lstStyle/>
                     <a:p>
                       <a:r>
-                        <a:rPr sz="1200">
+                        <a:rPr sz="1400">
                           <a:solidFill>
                             <a:srgbClr val="1A1A2E"/>
                           </a:solidFill>
@@ -4993,7 +4958,7 @@
                     <a:lstStyle/>
                     <a:p>
                       <a:r>
-                        <a:rPr sz="1200">
+                        <a:rPr sz="1400">
                           <a:solidFill>
                             <a:srgbClr val="1A1A2E"/>
                           </a:solidFill>
@@ -5022,7 +4987,42 @@
         </p:nvSpPr>
         <p:spPr>
           <a:xfrm>
-            <a:off x="11247120" y="6446520"/>
+            <a:off x="457200" y="6492240"/>
+            <a:ext cx="9601200" cy="320040"/>
+          </a:xfrm>
+          <a:prstGeom prst="rect">
+            <a:avLst/>
+          </a:prstGeom>
+          <a:noFill/>
+        </p:spPr>
+        <p:txBody>
+          <a:bodyPr wrap="square" lIns="45720" rIns="45720" tIns="27432" bIns="27432">
+            <a:spAutoFit/>
+          </a:bodyPr>
+          <a:lstStyle/>
+          <a:p>
+            <a:pPr algn="l"/>
+            <a:r>
+              <a:rPr sz="1000" b="0">
+                <a:solidFill>
+                  <a:srgbClr val="7A8A9A"/>
+                </a:solidFill>
+                <a:latin typeface="Yu Gothic"/>
+              </a:rPr>
+              <a:t>藪医者の学び / 2026-04-09 / WHOシステム思考</a:t>
+            </a:r>
+          </a:p>
+        </p:txBody>
+      </p:sp>
+      <p:sp>
+        <p:nvSpPr>
+          <p:cNvPr id="6" name="TextBox 5"/>
+          <p:cNvSpPr txBox="1"/>
+          <p:nvPr/>
+        </p:nvSpPr>
+        <p:spPr>
+          <a:xfrm>
+            <a:off x="11247120" y="6492240"/>
             <a:ext cx="914400" cy="320040"/>
           </a:xfrm>
           <a:prstGeom prst="rect">
@@ -5038,48 +5038,13 @@
           <a:p>
             <a:pPr algn="r"/>
             <a:r>
-              <a:rPr sz="900" b="0">
+              <a:rPr sz="1000" b="0">
                 <a:solidFill>
                   <a:srgbClr val="7A8A9A"/>
                 </a:solidFill>
                 <a:latin typeface="Yu Gothic"/>
               </a:rPr>
               <a:t>14 / 28</a:t>
-            </a:r>
-          </a:p>
-        </p:txBody>
-      </p:sp>
-      <p:sp>
-        <p:nvSpPr>
-          <p:cNvPr id="6" name="TextBox 5"/>
-          <p:cNvSpPr txBox="1"/>
-          <p:nvPr/>
-        </p:nvSpPr>
-        <p:spPr>
-          <a:xfrm>
-            <a:off x="457200" y="6446520"/>
-            <a:ext cx="7315200" cy="320040"/>
-          </a:xfrm>
-          <a:prstGeom prst="rect">
-            <a:avLst/>
-          </a:prstGeom>
-          <a:noFill/>
-        </p:spPr>
-        <p:txBody>
-          <a:bodyPr wrap="square" lIns="45720" rIns="45720" tIns="27432" bIns="27432">
-            <a:spAutoFit/>
-          </a:bodyPr>
-          <a:lstStyle/>
-          <a:p>
-            <a:pPr algn="l"/>
-            <a:r>
-              <a:rPr sz="900" b="0">
-                <a:solidFill>
-                  <a:srgbClr val="7A8A9A"/>
-                </a:solidFill>
-                <a:latin typeface="Yu Gothic"/>
-              </a:rPr>
-              <a:t>家庭医療科 勉強会 / 2026-04-09</a:t>
             </a:r>
           </a:p>
         </p:txBody>
@@ -5162,7 +5127,7 @@
         <p:spPr>
           <a:xfrm>
             <a:off x="457200" y="365760"/>
-            <a:ext cx="11430000" cy="822960"/>
+            <a:ext cx="11430000" cy="914400"/>
           </a:xfrm>
           <a:prstGeom prst="rect">
             <a:avLst/>
@@ -5177,7 +5142,7 @@
           <a:p>
             <a:pPr algn="l"/>
             <a:r>
-              <a:rPr sz="2600" b="1">
+              <a:rPr sz="3000" b="1">
                 <a:solidFill>
                   <a:srgbClr val="E89B3B"/>
                 </a:solidFill>
@@ -5196,7 +5161,42 @@
         </p:nvSpPr>
         <p:spPr>
           <a:xfrm>
-            <a:off x="11247120" y="6446520"/>
+            <a:off x="457200" y="6492240"/>
+            <a:ext cx="9601200" cy="320040"/>
+          </a:xfrm>
+          <a:prstGeom prst="rect">
+            <a:avLst/>
+          </a:prstGeom>
+          <a:noFill/>
+        </p:spPr>
+        <p:txBody>
+          <a:bodyPr wrap="square" lIns="45720" rIns="45720" tIns="27432" bIns="27432">
+            <a:spAutoFit/>
+          </a:bodyPr>
+          <a:lstStyle/>
+          <a:p>
+            <a:pPr algn="l"/>
+            <a:r>
+              <a:rPr sz="1000" b="0">
+                <a:solidFill>
+                  <a:srgbClr val="7A8A9A"/>
+                </a:solidFill>
+                <a:latin typeface="Yu Gothic"/>
+              </a:rPr>
+              <a:t>藪医者の学び / 2026-04-09 / WHOシステム思考</a:t>
+            </a:r>
+          </a:p>
+        </p:txBody>
+      </p:sp>
+      <p:sp>
+        <p:nvSpPr>
+          <p:cNvPr id="5" name="TextBox 4"/>
+          <p:cNvSpPr txBox="1"/>
+          <p:nvPr/>
+        </p:nvSpPr>
+        <p:spPr>
+          <a:xfrm>
+            <a:off x="11247120" y="6492240"/>
             <a:ext cx="914400" cy="320040"/>
           </a:xfrm>
           <a:prstGeom prst="rect">
@@ -5212,48 +5212,13 @@
           <a:p>
             <a:pPr algn="r"/>
             <a:r>
-              <a:rPr sz="900" b="0">
+              <a:rPr sz="1000" b="0">
                 <a:solidFill>
                   <a:srgbClr val="7A8A9A"/>
                 </a:solidFill>
                 <a:latin typeface="Yu Gothic"/>
               </a:rPr>
               <a:t>15 / 28</a:t>
-            </a:r>
-          </a:p>
-        </p:txBody>
-      </p:sp>
-      <p:sp>
-        <p:nvSpPr>
-          <p:cNvPr id="5" name="TextBox 4"/>
-          <p:cNvSpPr txBox="1"/>
-          <p:nvPr/>
-        </p:nvSpPr>
-        <p:spPr>
-          <a:xfrm>
-            <a:off x="457200" y="6446520"/>
-            <a:ext cx="7315200" cy="320040"/>
-          </a:xfrm>
-          <a:prstGeom prst="rect">
-            <a:avLst/>
-          </a:prstGeom>
-          <a:noFill/>
-        </p:spPr>
-        <p:txBody>
-          <a:bodyPr wrap="square" lIns="45720" rIns="45720" tIns="27432" bIns="27432">
-            <a:spAutoFit/>
-          </a:bodyPr>
-          <a:lstStyle/>
-          <a:p>
-            <a:pPr algn="l"/>
-            <a:r>
-              <a:rPr sz="900" b="0">
-                <a:solidFill>
-                  <a:srgbClr val="7A8A9A"/>
-                </a:solidFill>
-                <a:latin typeface="Yu Gothic"/>
-              </a:rPr>
-              <a:t>家庭医療科 勉強会 / 2026-04-09</a:t>
             </a:r>
           </a:p>
         </p:txBody>
@@ -5336,7 +5301,7 @@
         <p:spPr>
           <a:xfrm>
             <a:off x="457200" y="365760"/>
-            <a:ext cx="11430000" cy="822960"/>
+            <a:ext cx="11430000" cy="914400"/>
           </a:xfrm>
           <a:prstGeom prst="rect">
             <a:avLst/>
@@ -5351,7 +5316,7 @@
           <a:p>
             <a:pPr algn="l"/>
             <a:r>
-              <a:rPr sz="2600" b="1">
+              <a:rPr sz="3000" b="1">
                 <a:solidFill>
                   <a:srgbClr val="0D2B3E"/>
                 </a:solidFill>
@@ -5370,8 +5335,8 @@
         </p:nvSpPr>
         <p:spPr>
           <a:xfrm>
-            <a:off x="548640" y="1371600"/>
-            <a:ext cx="10972800" cy="3200400"/>
+            <a:off x="548640" y="1463040"/>
+            <a:ext cx="10972800" cy="3566160"/>
           </a:xfrm>
           <a:prstGeom prst="rect">
             <a:avLst/>
@@ -5386,7 +5351,7 @@
           <a:p>
             <a:pPr algn="l"/>
             <a:r>
-              <a:rPr sz="1400" b="0">
+              <a:rPr sz="1800" b="0">
                 <a:solidFill>
                   <a:srgbClr val="1A1A2E"/>
                 </a:solidFill>
@@ -5396,7 +5361,7 @@
             </a:r>
             <a:br/>
             <a:r>
-              <a:rPr sz="1400" b="0">
+              <a:rPr sz="1800" b="0">
                 <a:solidFill>
                   <a:srgbClr val="1A1A2E"/>
                 </a:solidFill>
@@ -5406,7 +5371,7 @@
             </a:r>
             <a:br/>
             <a:r>
-              <a:rPr sz="1400" b="0">
+              <a:rPr sz="1800" b="0">
                 <a:solidFill>
                   <a:srgbClr val="1A1A2E"/>
                 </a:solidFill>
@@ -5425,8 +5390,8 @@
         </p:nvSpPr>
         <p:spPr>
           <a:xfrm>
-            <a:off x="548640" y="2743200"/>
-            <a:ext cx="10972800" cy="2286000"/>
+            <a:off x="548640" y="3108960"/>
+            <a:ext cx="10972800" cy="2377439"/>
           </a:xfrm>
           <a:prstGeom prst="rect">
             <a:avLst/>
@@ -5440,7 +5405,7 @@
           <a:lstStyle/>
           <a:p>
             <a:r>
-              <a:rPr sz="1400">
+              <a:rPr sz="1800">
                 <a:solidFill>
                   <a:srgbClr val="1A1A2E"/>
                 </a:solidFill>
@@ -5451,7 +5416,7 @@
           </a:p>
           <a:p>
             <a:r>
-              <a:rPr sz="1400">
+              <a:rPr sz="1800">
                 <a:solidFill>
                   <a:srgbClr val="1A1A2E"/>
                 </a:solidFill>
@@ -5462,7 +5427,7 @@
           </a:p>
           <a:p>
             <a:r>
-              <a:rPr sz="1400">
+              <a:rPr sz="1800">
                 <a:solidFill>
                   <a:srgbClr val="1A1A2E"/>
                 </a:solidFill>
@@ -5481,7 +5446,42 @@
         </p:nvSpPr>
         <p:spPr>
           <a:xfrm>
-            <a:off x="11247120" y="6446520"/>
+            <a:off x="457200" y="6492240"/>
+            <a:ext cx="9601200" cy="320040"/>
+          </a:xfrm>
+          <a:prstGeom prst="rect">
+            <a:avLst/>
+          </a:prstGeom>
+          <a:noFill/>
+        </p:spPr>
+        <p:txBody>
+          <a:bodyPr wrap="square" lIns="45720" rIns="45720" tIns="27432" bIns="27432">
+            <a:spAutoFit/>
+          </a:bodyPr>
+          <a:lstStyle/>
+          <a:p>
+            <a:pPr algn="l"/>
+            <a:r>
+              <a:rPr sz="1000" b="0">
+                <a:solidFill>
+                  <a:srgbClr val="7A8A9A"/>
+                </a:solidFill>
+                <a:latin typeface="Yu Gothic"/>
+              </a:rPr>
+              <a:t>藪医者の学び / 2026-04-09 / WHOシステム思考</a:t>
+            </a:r>
+          </a:p>
+        </p:txBody>
+      </p:sp>
+      <p:sp>
+        <p:nvSpPr>
+          <p:cNvPr id="7" name="TextBox 6"/>
+          <p:cNvSpPr txBox="1"/>
+          <p:nvPr/>
+        </p:nvSpPr>
+        <p:spPr>
+          <a:xfrm>
+            <a:off x="11247120" y="6492240"/>
             <a:ext cx="914400" cy="320040"/>
           </a:xfrm>
           <a:prstGeom prst="rect">
@@ -5497,48 +5497,13 @@
           <a:p>
             <a:pPr algn="r"/>
             <a:r>
-              <a:rPr sz="900" b="0">
+              <a:rPr sz="1000" b="0">
                 <a:solidFill>
                   <a:srgbClr val="7A8A9A"/>
                 </a:solidFill>
                 <a:latin typeface="Yu Gothic"/>
               </a:rPr>
               <a:t>16 / 28</a:t>
-            </a:r>
-          </a:p>
-        </p:txBody>
-      </p:sp>
-      <p:sp>
-        <p:nvSpPr>
-          <p:cNvPr id="7" name="TextBox 6"/>
-          <p:cNvSpPr txBox="1"/>
-          <p:nvPr/>
-        </p:nvSpPr>
-        <p:spPr>
-          <a:xfrm>
-            <a:off x="457200" y="6446520"/>
-            <a:ext cx="7315200" cy="320040"/>
-          </a:xfrm>
-          <a:prstGeom prst="rect">
-            <a:avLst/>
-          </a:prstGeom>
-          <a:noFill/>
-        </p:spPr>
-        <p:txBody>
-          <a:bodyPr wrap="square" lIns="45720" rIns="45720" tIns="27432" bIns="27432">
-            <a:spAutoFit/>
-          </a:bodyPr>
-          <a:lstStyle/>
-          <a:p>
-            <a:pPr algn="l"/>
-            <a:r>
-              <a:rPr sz="900" b="0">
-                <a:solidFill>
-                  <a:srgbClr val="7A8A9A"/>
-                </a:solidFill>
-                <a:latin typeface="Yu Gothic"/>
-              </a:rPr>
-              <a:t>家庭医療科 勉強会 / 2026-04-09</a:t>
             </a:r>
           </a:p>
         </p:txBody>
@@ -5621,7 +5586,7 @@
         <p:spPr>
           <a:xfrm>
             <a:off x="457200" y="365760"/>
-            <a:ext cx="11430000" cy="822960"/>
+            <a:ext cx="11430000" cy="914400"/>
           </a:xfrm>
           <a:prstGeom prst="rect">
             <a:avLst/>
@@ -5636,7 +5601,7 @@
           <a:p>
             <a:pPr algn="l"/>
             <a:r>
-              <a:rPr sz="2600" b="1">
+              <a:rPr sz="3000" b="1">
                 <a:solidFill>
                   <a:srgbClr val="0D2B3E"/>
                 </a:solidFill>
@@ -5655,8 +5620,8 @@
         </p:nvSpPr>
         <p:spPr>
           <a:xfrm>
-            <a:off x="548640" y="1371600"/>
-            <a:ext cx="10972800" cy="3200400"/>
+            <a:off x="548640" y="1463040"/>
+            <a:ext cx="10972800" cy="3566160"/>
           </a:xfrm>
           <a:prstGeom prst="rect">
             <a:avLst/>
@@ -5671,7 +5636,7 @@
           <a:p>
             <a:pPr algn="l"/>
             <a:r>
-              <a:rPr sz="1400" b="0">
+              <a:rPr sz="1800" b="0">
                 <a:solidFill>
                   <a:srgbClr val="1A1A2E"/>
                 </a:solidFill>
@@ -5681,7 +5646,7 @@
             </a:r>
             <a:br/>
             <a:r>
-              <a:rPr sz="1400" b="0">
+              <a:rPr sz="1800" b="0">
                 <a:solidFill>
                   <a:srgbClr val="1A1A2E"/>
                 </a:solidFill>
@@ -5691,7 +5656,7 @@
             </a:r>
             <a:br/>
             <a:r>
-              <a:rPr sz="1400" b="0">
+              <a:rPr sz="1800" b="0">
                 <a:solidFill>
                   <a:srgbClr val="1A1A2E"/>
                 </a:solidFill>
@@ -5701,7 +5666,7 @@
             </a:r>
             <a:br/>
             <a:r>
-              <a:rPr sz="1400" b="0">
+              <a:rPr sz="1800" b="0">
                 <a:solidFill>
                   <a:srgbClr val="1A1A2E"/>
                 </a:solidFill>
@@ -5711,7 +5676,7 @@
             </a:r>
             <a:br/>
             <a:r>
-              <a:rPr sz="1400" b="0">
+              <a:rPr sz="1800" b="0">
                 <a:solidFill>
                   <a:srgbClr val="1A1A2E"/>
                 </a:solidFill>
@@ -5721,7 +5686,7 @@
             </a:r>
             <a:br/>
             <a:r>
-              <a:rPr sz="1400" b="0">
+              <a:rPr sz="1800" b="0">
                 <a:solidFill>
                   <a:srgbClr val="1A1A2E"/>
                 </a:solidFill>
@@ -5740,7 +5705,42 @@
         </p:nvSpPr>
         <p:spPr>
           <a:xfrm>
-            <a:off x="11247120" y="6446520"/>
+            <a:off x="457200" y="6492240"/>
+            <a:ext cx="9601200" cy="320040"/>
+          </a:xfrm>
+          <a:prstGeom prst="rect">
+            <a:avLst/>
+          </a:prstGeom>
+          <a:noFill/>
+        </p:spPr>
+        <p:txBody>
+          <a:bodyPr wrap="square" lIns="45720" rIns="45720" tIns="27432" bIns="27432">
+            <a:spAutoFit/>
+          </a:bodyPr>
+          <a:lstStyle/>
+          <a:p>
+            <a:pPr algn="l"/>
+            <a:r>
+              <a:rPr sz="1000" b="0">
+                <a:solidFill>
+                  <a:srgbClr val="7A8A9A"/>
+                </a:solidFill>
+                <a:latin typeface="Yu Gothic"/>
+              </a:rPr>
+              <a:t>藪医者の学び / 2026-04-09 / WHOシステム思考</a:t>
+            </a:r>
+          </a:p>
+        </p:txBody>
+      </p:sp>
+      <p:sp>
+        <p:nvSpPr>
+          <p:cNvPr id="6" name="TextBox 5"/>
+          <p:cNvSpPr txBox="1"/>
+          <p:nvPr/>
+        </p:nvSpPr>
+        <p:spPr>
+          <a:xfrm>
+            <a:off x="11247120" y="6492240"/>
             <a:ext cx="914400" cy="320040"/>
           </a:xfrm>
           <a:prstGeom prst="rect">
@@ -5756,48 +5756,13 @@
           <a:p>
             <a:pPr algn="r"/>
             <a:r>
-              <a:rPr sz="900" b="0">
+              <a:rPr sz="1000" b="0">
                 <a:solidFill>
                   <a:srgbClr val="7A8A9A"/>
                 </a:solidFill>
                 <a:latin typeface="Yu Gothic"/>
               </a:rPr>
               <a:t>17 / 28</a:t>
-            </a:r>
-          </a:p>
-        </p:txBody>
-      </p:sp>
-      <p:sp>
-        <p:nvSpPr>
-          <p:cNvPr id="6" name="TextBox 5"/>
-          <p:cNvSpPr txBox="1"/>
-          <p:nvPr/>
-        </p:nvSpPr>
-        <p:spPr>
-          <a:xfrm>
-            <a:off x="457200" y="6446520"/>
-            <a:ext cx="7315200" cy="320040"/>
-          </a:xfrm>
-          <a:prstGeom prst="rect">
-            <a:avLst/>
-          </a:prstGeom>
-          <a:noFill/>
-        </p:spPr>
-        <p:txBody>
-          <a:bodyPr wrap="square" lIns="45720" rIns="45720" tIns="27432" bIns="27432">
-            <a:spAutoFit/>
-          </a:bodyPr>
-          <a:lstStyle/>
-          <a:p>
-            <a:pPr algn="l"/>
-            <a:r>
-              <a:rPr sz="900" b="0">
-                <a:solidFill>
-                  <a:srgbClr val="7A8A9A"/>
-                </a:solidFill>
-                <a:latin typeface="Yu Gothic"/>
-              </a:rPr>
-              <a:t>家庭医療科 勉強会 / 2026-04-09</a:t>
             </a:r>
           </a:p>
         </p:txBody>
@@ -5880,7 +5845,7 @@
         <p:spPr>
           <a:xfrm>
             <a:off x="457200" y="365760"/>
-            <a:ext cx="11430000" cy="822960"/>
+            <a:ext cx="11430000" cy="914400"/>
           </a:xfrm>
           <a:prstGeom prst="rect">
             <a:avLst/>
@@ -5895,7 +5860,7 @@
           <a:p>
             <a:pPr algn="l"/>
             <a:r>
-              <a:rPr sz="2600" b="1">
+              <a:rPr sz="3000" b="1">
                 <a:solidFill>
                   <a:srgbClr val="E89B3B"/>
                 </a:solidFill>
@@ -5914,7 +5879,42 @@
         </p:nvSpPr>
         <p:spPr>
           <a:xfrm>
-            <a:off x="11247120" y="6446520"/>
+            <a:off x="457200" y="6492240"/>
+            <a:ext cx="9601200" cy="320040"/>
+          </a:xfrm>
+          <a:prstGeom prst="rect">
+            <a:avLst/>
+          </a:prstGeom>
+          <a:noFill/>
+        </p:spPr>
+        <p:txBody>
+          <a:bodyPr wrap="square" lIns="45720" rIns="45720" tIns="27432" bIns="27432">
+            <a:spAutoFit/>
+          </a:bodyPr>
+          <a:lstStyle/>
+          <a:p>
+            <a:pPr algn="l"/>
+            <a:r>
+              <a:rPr sz="1000" b="0">
+                <a:solidFill>
+                  <a:srgbClr val="7A8A9A"/>
+                </a:solidFill>
+                <a:latin typeface="Yu Gothic"/>
+              </a:rPr>
+              <a:t>藪医者の学び / 2026-04-09 / WHOシステム思考</a:t>
+            </a:r>
+          </a:p>
+        </p:txBody>
+      </p:sp>
+      <p:sp>
+        <p:nvSpPr>
+          <p:cNvPr id="5" name="TextBox 4"/>
+          <p:cNvSpPr txBox="1"/>
+          <p:nvPr/>
+        </p:nvSpPr>
+        <p:spPr>
+          <a:xfrm>
+            <a:off x="11247120" y="6492240"/>
             <a:ext cx="914400" cy="320040"/>
           </a:xfrm>
           <a:prstGeom prst="rect">
@@ -5930,48 +5930,13 @@
           <a:p>
             <a:pPr algn="r"/>
             <a:r>
-              <a:rPr sz="900" b="0">
+              <a:rPr sz="1000" b="0">
                 <a:solidFill>
                   <a:srgbClr val="7A8A9A"/>
                 </a:solidFill>
                 <a:latin typeface="Yu Gothic"/>
               </a:rPr>
               <a:t>18 / 28</a:t>
-            </a:r>
-          </a:p>
-        </p:txBody>
-      </p:sp>
-      <p:sp>
-        <p:nvSpPr>
-          <p:cNvPr id="5" name="TextBox 4"/>
-          <p:cNvSpPr txBox="1"/>
-          <p:nvPr/>
-        </p:nvSpPr>
-        <p:spPr>
-          <a:xfrm>
-            <a:off x="457200" y="6446520"/>
-            <a:ext cx="7315200" cy="320040"/>
-          </a:xfrm>
-          <a:prstGeom prst="rect">
-            <a:avLst/>
-          </a:prstGeom>
-          <a:noFill/>
-        </p:spPr>
-        <p:txBody>
-          <a:bodyPr wrap="square" lIns="45720" rIns="45720" tIns="27432" bIns="27432">
-            <a:spAutoFit/>
-          </a:bodyPr>
-          <a:lstStyle/>
-          <a:p>
-            <a:pPr algn="l"/>
-            <a:r>
-              <a:rPr sz="900" b="0">
-                <a:solidFill>
-                  <a:srgbClr val="7A8A9A"/>
-                </a:solidFill>
-                <a:latin typeface="Yu Gothic"/>
-              </a:rPr>
-              <a:t>家庭医療科 勉強会 / 2026-04-09</a:t>
             </a:r>
           </a:p>
         </p:txBody>
@@ -6054,7 +6019,7 @@
         <p:spPr>
           <a:xfrm>
             <a:off x="457200" y="365760"/>
-            <a:ext cx="11430000" cy="822960"/>
+            <a:ext cx="11430000" cy="914400"/>
           </a:xfrm>
           <a:prstGeom prst="rect">
             <a:avLst/>
@@ -6069,7 +6034,7 @@
           <a:p>
             <a:pPr algn="l"/>
             <a:r>
-              <a:rPr sz="2600" b="1">
+              <a:rPr sz="3000" b="1">
                 <a:solidFill>
                   <a:srgbClr val="0D2B3E"/>
                 </a:solidFill>
@@ -6088,8 +6053,8 @@
         </p:nvSpPr>
         <p:spPr>
           <a:xfrm>
-            <a:off x="548640" y="1371600"/>
-            <a:ext cx="10972800" cy="3200400"/>
+            <a:off x="548640" y="1463040"/>
+            <a:ext cx="10972800" cy="3566160"/>
           </a:xfrm>
           <a:prstGeom prst="rect">
             <a:avLst/>
@@ -6104,7 +6069,7 @@
           <a:p>
             <a:pPr algn="l"/>
             <a:r>
-              <a:rPr sz="1400" b="0">
+              <a:rPr sz="1800" b="0">
                 <a:solidFill>
                   <a:srgbClr val="1A1A2E"/>
                 </a:solidFill>
@@ -6123,8 +6088,8 @@
         </p:nvSpPr>
         <p:spPr>
           <a:xfrm>
-            <a:off x="548640" y="2743200"/>
-            <a:ext cx="10972800" cy="2286000"/>
+            <a:off x="548640" y="3108960"/>
+            <a:ext cx="10972800" cy="2377439"/>
           </a:xfrm>
           <a:prstGeom prst="rect">
             <a:avLst/>
@@ -6138,7 +6103,7 @@
           <a:lstStyle/>
           <a:p>
             <a:r>
-              <a:rPr sz="1400">
+              <a:rPr sz="1800">
                 <a:solidFill>
                   <a:srgbClr val="1A1A2E"/>
                 </a:solidFill>
@@ -6149,7 +6114,7 @@
           </a:p>
           <a:p>
             <a:r>
-              <a:rPr sz="1400">
+              <a:rPr sz="1800">
                 <a:solidFill>
                   <a:srgbClr val="1A1A2E"/>
                 </a:solidFill>
@@ -6160,7 +6125,7 @@
           </a:p>
           <a:p>
             <a:r>
-              <a:rPr sz="1400">
+              <a:rPr sz="1800">
                 <a:solidFill>
                   <a:srgbClr val="1A1A2E"/>
                 </a:solidFill>
@@ -6179,7 +6144,42 @@
         </p:nvSpPr>
         <p:spPr>
           <a:xfrm>
-            <a:off x="11247120" y="6446520"/>
+            <a:off x="457200" y="6492240"/>
+            <a:ext cx="9601200" cy="320040"/>
+          </a:xfrm>
+          <a:prstGeom prst="rect">
+            <a:avLst/>
+          </a:prstGeom>
+          <a:noFill/>
+        </p:spPr>
+        <p:txBody>
+          <a:bodyPr wrap="square" lIns="45720" rIns="45720" tIns="27432" bIns="27432">
+            <a:spAutoFit/>
+          </a:bodyPr>
+          <a:lstStyle/>
+          <a:p>
+            <a:pPr algn="l"/>
+            <a:r>
+              <a:rPr sz="1000" b="0">
+                <a:solidFill>
+                  <a:srgbClr val="7A8A9A"/>
+                </a:solidFill>
+                <a:latin typeface="Yu Gothic"/>
+              </a:rPr>
+              <a:t>藪医者の学び / 2026-04-09 / WHOシステム思考</a:t>
+            </a:r>
+          </a:p>
+        </p:txBody>
+      </p:sp>
+      <p:sp>
+        <p:nvSpPr>
+          <p:cNvPr id="7" name="TextBox 6"/>
+          <p:cNvSpPr txBox="1"/>
+          <p:nvPr/>
+        </p:nvSpPr>
+        <p:spPr>
+          <a:xfrm>
+            <a:off x="11247120" y="6492240"/>
             <a:ext cx="914400" cy="320040"/>
           </a:xfrm>
           <a:prstGeom prst="rect">
@@ -6195,48 +6195,13 @@
           <a:p>
             <a:pPr algn="r"/>
             <a:r>
-              <a:rPr sz="900" b="0">
+              <a:rPr sz="1000" b="0">
                 <a:solidFill>
                   <a:srgbClr val="7A8A9A"/>
                 </a:solidFill>
                 <a:latin typeface="Yu Gothic"/>
               </a:rPr>
               <a:t>19 / 28</a:t>
-            </a:r>
-          </a:p>
-        </p:txBody>
-      </p:sp>
-      <p:sp>
-        <p:nvSpPr>
-          <p:cNvPr id="7" name="TextBox 6"/>
-          <p:cNvSpPr txBox="1"/>
-          <p:nvPr/>
-        </p:nvSpPr>
-        <p:spPr>
-          <a:xfrm>
-            <a:off x="457200" y="6446520"/>
-            <a:ext cx="7315200" cy="320040"/>
-          </a:xfrm>
-          <a:prstGeom prst="rect">
-            <a:avLst/>
-          </a:prstGeom>
-          <a:noFill/>
-        </p:spPr>
-        <p:txBody>
-          <a:bodyPr wrap="square" lIns="45720" rIns="45720" tIns="27432" bIns="27432">
-            <a:spAutoFit/>
-          </a:bodyPr>
-          <a:lstStyle/>
-          <a:p>
-            <a:pPr algn="l"/>
-            <a:r>
-              <a:rPr sz="900" b="0">
-                <a:solidFill>
-                  <a:srgbClr val="7A8A9A"/>
-                </a:solidFill>
-                <a:latin typeface="Yu Gothic"/>
-              </a:rPr>
-              <a:t>家庭医療科 勉強会 / 2026-04-09</a:t>
             </a:r>
           </a:p>
         </p:txBody>
@@ -6319,7 +6284,7 @@
         <p:spPr>
           <a:xfrm>
             <a:off x="457200" y="365760"/>
-            <a:ext cx="11430000" cy="822960"/>
+            <a:ext cx="11430000" cy="914400"/>
           </a:xfrm>
           <a:prstGeom prst="rect">
             <a:avLst/>
@@ -6334,7 +6299,7 @@
           <a:p>
             <a:pPr algn="l"/>
             <a:r>
-              <a:rPr sz="2600" b="1">
+              <a:rPr sz="3000" b="1">
                 <a:solidFill>
                   <a:srgbClr val="0D2B3E"/>
                 </a:solidFill>
@@ -6353,8 +6318,8 @@
         </p:nvSpPr>
         <p:spPr>
           <a:xfrm>
-            <a:off x="548640" y="1371600"/>
-            <a:ext cx="10972800" cy="3200400"/>
+            <a:off x="548640" y="1463040"/>
+            <a:ext cx="10972800" cy="3566160"/>
           </a:xfrm>
           <a:prstGeom prst="rect">
             <a:avLst/>
@@ -6369,7 +6334,7 @@
           <a:p>
             <a:pPr algn="l"/>
             <a:r>
-              <a:rPr sz="1400" b="0">
+              <a:rPr sz="1800" b="0">
                 <a:solidFill>
                   <a:srgbClr val="1A1A2E"/>
                 </a:solidFill>
@@ -6379,7 +6344,7 @@
             </a:r>
             <a:br/>
             <a:r>
-              <a:rPr sz="1400" b="0">
+              <a:rPr sz="1800" b="0">
                 <a:solidFill>
                   <a:srgbClr val="1A1A2E"/>
                 </a:solidFill>
@@ -6389,7 +6354,7 @@
             </a:r>
             <a:br/>
             <a:r>
-              <a:rPr sz="1400" b="0">
+              <a:rPr sz="1800" b="0">
                 <a:solidFill>
                   <a:srgbClr val="1A1A2E"/>
                 </a:solidFill>
@@ -6399,7 +6364,7 @@
             </a:r>
             <a:br/>
             <a:r>
-              <a:rPr sz="1400" b="0">
+              <a:rPr sz="1800" b="0">
                 <a:solidFill>
                   <a:srgbClr val="1A1A2E"/>
                 </a:solidFill>
@@ -6409,7 +6374,7 @@
             </a:r>
             <a:br/>
             <a:r>
-              <a:rPr sz="1400" b="0">
+              <a:rPr sz="1800" b="0">
                 <a:solidFill>
                   <a:srgbClr val="1A1A2E"/>
                 </a:solidFill>
@@ -6428,7 +6393,42 @@
         </p:nvSpPr>
         <p:spPr>
           <a:xfrm>
-            <a:off x="11247120" y="6446520"/>
+            <a:off x="457200" y="6492240"/>
+            <a:ext cx="9601200" cy="320040"/>
+          </a:xfrm>
+          <a:prstGeom prst="rect">
+            <a:avLst/>
+          </a:prstGeom>
+          <a:noFill/>
+        </p:spPr>
+        <p:txBody>
+          <a:bodyPr wrap="square" lIns="45720" rIns="45720" tIns="27432" bIns="27432">
+            <a:spAutoFit/>
+          </a:bodyPr>
+          <a:lstStyle/>
+          <a:p>
+            <a:pPr algn="l"/>
+            <a:r>
+              <a:rPr sz="1000" b="0">
+                <a:solidFill>
+                  <a:srgbClr val="7A8A9A"/>
+                </a:solidFill>
+                <a:latin typeface="Yu Gothic"/>
+              </a:rPr>
+              <a:t>藪医者の学び / 2026-04-09 / WHOシステム思考</a:t>
+            </a:r>
+          </a:p>
+        </p:txBody>
+      </p:sp>
+      <p:sp>
+        <p:nvSpPr>
+          <p:cNvPr id="6" name="TextBox 5"/>
+          <p:cNvSpPr txBox="1"/>
+          <p:nvPr/>
+        </p:nvSpPr>
+        <p:spPr>
+          <a:xfrm>
+            <a:off x="11247120" y="6492240"/>
             <a:ext cx="914400" cy="320040"/>
           </a:xfrm>
           <a:prstGeom prst="rect">
@@ -6444,48 +6444,13 @@
           <a:p>
             <a:pPr algn="r"/>
             <a:r>
-              <a:rPr sz="900" b="0">
+              <a:rPr sz="1000" b="0">
                 <a:solidFill>
                   <a:srgbClr val="7A8A9A"/>
                 </a:solidFill>
                 <a:latin typeface="Yu Gothic"/>
               </a:rPr>
               <a:t>2 / 28</a:t>
-            </a:r>
-          </a:p>
-        </p:txBody>
-      </p:sp>
-      <p:sp>
-        <p:nvSpPr>
-          <p:cNvPr id="6" name="TextBox 5"/>
-          <p:cNvSpPr txBox="1"/>
-          <p:nvPr/>
-        </p:nvSpPr>
-        <p:spPr>
-          <a:xfrm>
-            <a:off x="457200" y="6446520"/>
-            <a:ext cx="7315200" cy="320040"/>
-          </a:xfrm>
-          <a:prstGeom prst="rect">
-            <a:avLst/>
-          </a:prstGeom>
-          <a:noFill/>
-        </p:spPr>
-        <p:txBody>
-          <a:bodyPr wrap="square" lIns="45720" rIns="45720" tIns="27432" bIns="27432">
-            <a:spAutoFit/>
-          </a:bodyPr>
-          <a:lstStyle/>
-          <a:p>
-            <a:pPr algn="l"/>
-            <a:r>
-              <a:rPr sz="900" b="0">
-                <a:solidFill>
-                  <a:srgbClr val="7A8A9A"/>
-                </a:solidFill>
-                <a:latin typeface="Yu Gothic"/>
-              </a:rPr>
-              <a:t>家庭医療科 勉強会 / 2026-04-09</a:t>
             </a:r>
           </a:p>
         </p:txBody>
@@ -6568,7 +6533,7 @@
         <p:spPr>
           <a:xfrm>
             <a:off x="457200" y="365760"/>
-            <a:ext cx="11430000" cy="822960"/>
+            <a:ext cx="11430000" cy="914400"/>
           </a:xfrm>
           <a:prstGeom prst="rect">
             <a:avLst/>
@@ -6583,7 +6548,7 @@
           <a:p>
             <a:pPr algn="l"/>
             <a:r>
-              <a:rPr sz="2600" b="1">
+              <a:rPr sz="3000" b="1">
                 <a:solidFill>
                   <a:srgbClr val="0D2B3E"/>
                 </a:solidFill>
@@ -6602,8 +6567,8 @@
         </p:nvSpPr>
         <p:spPr>
           <a:xfrm>
-            <a:off x="548640" y="1371600"/>
-            <a:ext cx="10972800" cy="3200400"/>
+            <a:off x="548640" y="1463040"/>
+            <a:ext cx="10972800" cy="3566160"/>
           </a:xfrm>
           <a:prstGeom prst="rect">
             <a:avLst/>
@@ -6618,7 +6583,7 @@
           <a:p>
             <a:pPr algn="l"/>
             <a:r>
-              <a:rPr sz="1400" b="0">
+              <a:rPr sz="1800" b="0">
                 <a:solidFill>
                   <a:srgbClr val="1A1A2E"/>
                 </a:solidFill>
@@ -6628,7 +6593,7 @@
             </a:r>
             <a:br/>
             <a:r>
-              <a:rPr sz="1400" b="0">
+              <a:rPr sz="1800" b="0">
                 <a:solidFill>
                   <a:srgbClr val="1A1A2E"/>
                 </a:solidFill>
@@ -6647,8 +6612,8 @@
         </p:nvSpPr>
         <p:spPr>
           <a:xfrm>
-            <a:off x="548640" y="2743200"/>
-            <a:ext cx="10972800" cy="2286000"/>
+            <a:off x="548640" y="3108960"/>
+            <a:ext cx="10972800" cy="2377439"/>
           </a:xfrm>
           <a:prstGeom prst="rect">
             <a:avLst/>
@@ -6662,7 +6627,7 @@
           <a:lstStyle/>
           <a:p>
             <a:r>
-              <a:rPr sz="1400">
+              <a:rPr sz="1800">
                 <a:solidFill>
                   <a:srgbClr val="1A1A2E"/>
                 </a:solidFill>
@@ -6673,7 +6638,7 @@
           </a:p>
           <a:p>
             <a:r>
-              <a:rPr sz="1400">
+              <a:rPr sz="1800">
                 <a:solidFill>
                   <a:srgbClr val="1A1A2E"/>
                 </a:solidFill>
@@ -6684,7 +6649,7 @@
           </a:p>
           <a:p>
             <a:r>
-              <a:rPr sz="1400">
+              <a:rPr sz="1800">
                 <a:solidFill>
                   <a:srgbClr val="1A1A2E"/>
                 </a:solidFill>
@@ -6703,7 +6668,42 @@
         </p:nvSpPr>
         <p:spPr>
           <a:xfrm>
-            <a:off x="11247120" y="6446520"/>
+            <a:off x="457200" y="6492240"/>
+            <a:ext cx="9601200" cy="320040"/>
+          </a:xfrm>
+          <a:prstGeom prst="rect">
+            <a:avLst/>
+          </a:prstGeom>
+          <a:noFill/>
+        </p:spPr>
+        <p:txBody>
+          <a:bodyPr wrap="square" lIns="45720" rIns="45720" tIns="27432" bIns="27432">
+            <a:spAutoFit/>
+          </a:bodyPr>
+          <a:lstStyle/>
+          <a:p>
+            <a:pPr algn="l"/>
+            <a:r>
+              <a:rPr sz="1000" b="0">
+                <a:solidFill>
+                  <a:srgbClr val="7A8A9A"/>
+                </a:solidFill>
+                <a:latin typeface="Yu Gothic"/>
+              </a:rPr>
+              <a:t>藪医者の学び / 2026-04-09 / WHOシステム思考</a:t>
+            </a:r>
+          </a:p>
+        </p:txBody>
+      </p:sp>
+      <p:sp>
+        <p:nvSpPr>
+          <p:cNvPr id="7" name="TextBox 6"/>
+          <p:cNvSpPr txBox="1"/>
+          <p:nvPr/>
+        </p:nvSpPr>
+        <p:spPr>
+          <a:xfrm>
+            <a:off x="11247120" y="6492240"/>
             <a:ext cx="914400" cy="320040"/>
           </a:xfrm>
           <a:prstGeom prst="rect">
@@ -6719,48 +6719,13 @@
           <a:p>
             <a:pPr algn="r"/>
             <a:r>
-              <a:rPr sz="900" b="0">
+              <a:rPr sz="1000" b="0">
                 <a:solidFill>
                   <a:srgbClr val="7A8A9A"/>
                 </a:solidFill>
                 <a:latin typeface="Yu Gothic"/>
               </a:rPr>
               <a:t>20 / 28</a:t>
-            </a:r>
-          </a:p>
-        </p:txBody>
-      </p:sp>
-      <p:sp>
-        <p:nvSpPr>
-          <p:cNvPr id="7" name="TextBox 6"/>
-          <p:cNvSpPr txBox="1"/>
-          <p:nvPr/>
-        </p:nvSpPr>
-        <p:spPr>
-          <a:xfrm>
-            <a:off x="457200" y="6446520"/>
-            <a:ext cx="7315200" cy="320040"/>
-          </a:xfrm>
-          <a:prstGeom prst="rect">
-            <a:avLst/>
-          </a:prstGeom>
-          <a:noFill/>
-        </p:spPr>
-        <p:txBody>
-          <a:bodyPr wrap="square" lIns="45720" rIns="45720" tIns="27432" bIns="27432">
-            <a:spAutoFit/>
-          </a:bodyPr>
-          <a:lstStyle/>
-          <a:p>
-            <a:pPr algn="l"/>
-            <a:r>
-              <a:rPr sz="900" b="0">
-                <a:solidFill>
-                  <a:srgbClr val="7A8A9A"/>
-                </a:solidFill>
-                <a:latin typeface="Yu Gothic"/>
-              </a:rPr>
-              <a:t>家庭医療科 勉強会 / 2026-04-09</a:t>
             </a:r>
           </a:p>
         </p:txBody>
@@ -6843,7 +6808,7 @@
         <p:spPr>
           <a:xfrm>
             <a:off x="457200" y="365760"/>
-            <a:ext cx="11430000" cy="822960"/>
+            <a:ext cx="11430000" cy="914400"/>
           </a:xfrm>
           <a:prstGeom prst="rect">
             <a:avLst/>
@@ -6858,7 +6823,7 @@
           <a:p>
             <a:pPr algn="l"/>
             <a:r>
-              <a:rPr sz="2600" b="1">
+              <a:rPr sz="3000" b="1">
                 <a:solidFill>
                   <a:srgbClr val="E89B3B"/>
                 </a:solidFill>
@@ -6877,7 +6842,42 @@
         </p:nvSpPr>
         <p:spPr>
           <a:xfrm>
-            <a:off x="11247120" y="6446520"/>
+            <a:off x="457200" y="6492240"/>
+            <a:ext cx="9601200" cy="320040"/>
+          </a:xfrm>
+          <a:prstGeom prst="rect">
+            <a:avLst/>
+          </a:prstGeom>
+          <a:noFill/>
+        </p:spPr>
+        <p:txBody>
+          <a:bodyPr wrap="square" lIns="45720" rIns="45720" tIns="27432" bIns="27432">
+            <a:spAutoFit/>
+          </a:bodyPr>
+          <a:lstStyle/>
+          <a:p>
+            <a:pPr algn="l"/>
+            <a:r>
+              <a:rPr sz="1000" b="0">
+                <a:solidFill>
+                  <a:srgbClr val="7A8A9A"/>
+                </a:solidFill>
+                <a:latin typeface="Yu Gothic"/>
+              </a:rPr>
+              <a:t>藪医者の学び / 2026-04-09 / WHOシステム思考</a:t>
+            </a:r>
+          </a:p>
+        </p:txBody>
+      </p:sp>
+      <p:sp>
+        <p:nvSpPr>
+          <p:cNvPr id="5" name="TextBox 4"/>
+          <p:cNvSpPr txBox="1"/>
+          <p:nvPr/>
+        </p:nvSpPr>
+        <p:spPr>
+          <a:xfrm>
+            <a:off x="11247120" y="6492240"/>
             <a:ext cx="914400" cy="320040"/>
           </a:xfrm>
           <a:prstGeom prst="rect">
@@ -6893,48 +6893,13 @@
           <a:p>
             <a:pPr algn="r"/>
             <a:r>
-              <a:rPr sz="900" b="0">
+              <a:rPr sz="1000" b="0">
                 <a:solidFill>
                   <a:srgbClr val="7A8A9A"/>
                 </a:solidFill>
                 <a:latin typeface="Yu Gothic"/>
               </a:rPr>
               <a:t>21 / 28</a:t>
-            </a:r>
-          </a:p>
-        </p:txBody>
-      </p:sp>
-      <p:sp>
-        <p:nvSpPr>
-          <p:cNvPr id="5" name="TextBox 4"/>
-          <p:cNvSpPr txBox="1"/>
-          <p:nvPr/>
-        </p:nvSpPr>
-        <p:spPr>
-          <a:xfrm>
-            <a:off x="457200" y="6446520"/>
-            <a:ext cx="7315200" cy="320040"/>
-          </a:xfrm>
-          <a:prstGeom prst="rect">
-            <a:avLst/>
-          </a:prstGeom>
-          <a:noFill/>
-        </p:spPr>
-        <p:txBody>
-          <a:bodyPr wrap="square" lIns="45720" rIns="45720" tIns="27432" bIns="27432">
-            <a:spAutoFit/>
-          </a:bodyPr>
-          <a:lstStyle/>
-          <a:p>
-            <a:pPr algn="l"/>
-            <a:r>
-              <a:rPr sz="900" b="0">
-                <a:solidFill>
-                  <a:srgbClr val="7A8A9A"/>
-                </a:solidFill>
-                <a:latin typeface="Yu Gothic"/>
-              </a:rPr>
-              <a:t>家庭医療科 勉強会 / 2026-04-09</a:t>
             </a:r>
           </a:p>
         </p:txBody>
@@ -7017,7 +6982,7 @@
         <p:spPr>
           <a:xfrm>
             <a:off x="457200" y="365760"/>
-            <a:ext cx="11430000" cy="822960"/>
+            <a:ext cx="11430000" cy="914400"/>
           </a:xfrm>
           <a:prstGeom prst="rect">
             <a:avLst/>
@@ -7032,7 +6997,7 @@
           <a:p>
             <a:pPr algn="l"/>
             <a:r>
-              <a:rPr sz="2600" b="1">
+              <a:rPr sz="3000" b="1">
                 <a:solidFill>
                   <a:srgbClr val="0D2B3E"/>
                 </a:solidFill>
@@ -7051,8 +7016,8 @@
         </p:nvSpPr>
         <p:spPr>
           <a:xfrm>
-            <a:off x="548640" y="1371600"/>
-            <a:ext cx="10972800" cy="3200400"/>
+            <a:off x="548640" y="1463040"/>
+            <a:ext cx="10972800" cy="3566160"/>
           </a:xfrm>
           <a:prstGeom prst="rect">
             <a:avLst/>
@@ -7067,7 +7032,7 @@
           <a:p>
             <a:pPr algn="l"/>
             <a:r>
-              <a:rPr sz="1400" b="0">
+              <a:rPr sz="1800" b="0">
                 <a:solidFill>
                   <a:srgbClr val="1A1A2E"/>
                 </a:solidFill>
@@ -7077,7 +7042,7 @@
             </a:r>
             <a:br/>
             <a:r>
-              <a:rPr sz="1400" b="0">
+              <a:rPr sz="1800" b="0">
                 <a:solidFill>
                   <a:srgbClr val="1A1A2E"/>
                 </a:solidFill>
@@ -7096,8 +7061,8 @@
         </p:nvSpPr>
         <p:spPr>
           <a:xfrm>
-            <a:off x="548640" y="2743200"/>
-            <a:ext cx="10972800" cy="2286000"/>
+            <a:off x="548640" y="3108960"/>
+            <a:ext cx="10972800" cy="2377439"/>
           </a:xfrm>
           <a:prstGeom prst="rect">
             <a:avLst/>
@@ -7111,7 +7076,7 @@
           <a:lstStyle/>
           <a:p>
             <a:r>
-              <a:rPr sz="1400">
+              <a:rPr sz="1800">
                 <a:solidFill>
                   <a:srgbClr val="1A1A2E"/>
                 </a:solidFill>
@@ -7122,7 +7087,7 @@
           </a:p>
           <a:p>
             <a:r>
-              <a:rPr sz="1400">
+              <a:rPr sz="1800">
                 <a:solidFill>
                   <a:srgbClr val="1A1A2E"/>
                 </a:solidFill>
@@ -7133,7 +7098,7 @@
           </a:p>
           <a:p>
             <a:r>
-              <a:rPr sz="1400">
+              <a:rPr sz="1800">
                 <a:solidFill>
                   <a:srgbClr val="1A1A2E"/>
                 </a:solidFill>
@@ -7152,7 +7117,42 @@
         </p:nvSpPr>
         <p:spPr>
           <a:xfrm>
-            <a:off x="11247120" y="6446520"/>
+            <a:off x="457200" y="6492240"/>
+            <a:ext cx="9601200" cy="320040"/>
+          </a:xfrm>
+          <a:prstGeom prst="rect">
+            <a:avLst/>
+          </a:prstGeom>
+          <a:noFill/>
+        </p:spPr>
+        <p:txBody>
+          <a:bodyPr wrap="square" lIns="45720" rIns="45720" tIns="27432" bIns="27432">
+            <a:spAutoFit/>
+          </a:bodyPr>
+          <a:lstStyle/>
+          <a:p>
+            <a:pPr algn="l"/>
+            <a:r>
+              <a:rPr sz="1000" b="0">
+                <a:solidFill>
+                  <a:srgbClr val="7A8A9A"/>
+                </a:solidFill>
+                <a:latin typeface="Yu Gothic"/>
+              </a:rPr>
+              <a:t>藪医者の学び / 2026-04-09 / WHOシステム思考</a:t>
+            </a:r>
+          </a:p>
+        </p:txBody>
+      </p:sp>
+      <p:sp>
+        <p:nvSpPr>
+          <p:cNvPr id="7" name="TextBox 6"/>
+          <p:cNvSpPr txBox="1"/>
+          <p:nvPr/>
+        </p:nvSpPr>
+        <p:spPr>
+          <a:xfrm>
+            <a:off x="11247120" y="6492240"/>
             <a:ext cx="914400" cy="320040"/>
           </a:xfrm>
           <a:prstGeom prst="rect">
@@ -7168,48 +7168,13 @@
           <a:p>
             <a:pPr algn="r"/>
             <a:r>
-              <a:rPr sz="900" b="0">
+              <a:rPr sz="1000" b="0">
                 <a:solidFill>
                   <a:srgbClr val="7A8A9A"/>
                 </a:solidFill>
                 <a:latin typeface="Yu Gothic"/>
               </a:rPr>
               <a:t>22 / 28</a:t>
-            </a:r>
-          </a:p>
-        </p:txBody>
-      </p:sp>
-      <p:sp>
-        <p:nvSpPr>
-          <p:cNvPr id="7" name="TextBox 6"/>
-          <p:cNvSpPr txBox="1"/>
-          <p:nvPr/>
-        </p:nvSpPr>
-        <p:spPr>
-          <a:xfrm>
-            <a:off x="457200" y="6446520"/>
-            <a:ext cx="7315200" cy="320040"/>
-          </a:xfrm>
-          <a:prstGeom prst="rect">
-            <a:avLst/>
-          </a:prstGeom>
-          <a:noFill/>
-        </p:spPr>
-        <p:txBody>
-          <a:bodyPr wrap="square" lIns="45720" rIns="45720" tIns="27432" bIns="27432">
-            <a:spAutoFit/>
-          </a:bodyPr>
-          <a:lstStyle/>
-          <a:p>
-            <a:pPr algn="l"/>
-            <a:r>
-              <a:rPr sz="900" b="0">
-                <a:solidFill>
-                  <a:srgbClr val="7A8A9A"/>
-                </a:solidFill>
-                <a:latin typeface="Yu Gothic"/>
-              </a:rPr>
-              <a:t>家庭医療科 勉強会 / 2026-04-09</a:t>
             </a:r>
           </a:p>
         </p:txBody>
@@ -7292,7 +7257,7 @@
         <p:spPr>
           <a:xfrm>
             <a:off x="457200" y="365760"/>
-            <a:ext cx="11430000" cy="822960"/>
+            <a:ext cx="11430000" cy="914400"/>
           </a:xfrm>
           <a:prstGeom prst="rect">
             <a:avLst/>
@@ -7307,7 +7272,7 @@
           <a:p>
             <a:pPr algn="l"/>
             <a:r>
-              <a:rPr sz="2600" b="1">
+              <a:rPr sz="3000" b="1">
                 <a:solidFill>
                   <a:srgbClr val="0D2B3E"/>
                 </a:solidFill>
@@ -7326,8 +7291,8 @@
         </p:nvSpPr>
         <p:spPr>
           <a:xfrm>
-            <a:off x="548640" y="1371600"/>
-            <a:ext cx="10972800" cy="3200400"/>
+            <a:off x="548640" y="1463040"/>
+            <a:ext cx="10972800" cy="3566160"/>
           </a:xfrm>
           <a:prstGeom prst="rect">
             <a:avLst/>
@@ -7342,7 +7307,7 @@
           <a:p>
             <a:pPr algn="l"/>
             <a:r>
-              <a:rPr sz="1400" b="0">
+              <a:rPr sz="1800" b="0">
                 <a:solidFill>
                   <a:srgbClr val="1A1A2E"/>
                 </a:solidFill>
@@ -7352,7 +7317,7 @@
             </a:r>
             <a:br/>
             <a:r>
-              <a:rPr sz="1400" b="0">
+              <a:rPr sz="1800" b="0">
                 <a:solidFill>
                   <a:srgbClr val="1A1A2E"/>
                 </a:solidFill>
@@ -7362,7 +7327,7 @@
             </a:r>
             <a:br/>
             <a:r>
-              <a:rPr sz="1400" b="0">
+              <a:rPr sz="1800" b="0">
                 <a:solidFill>
                   <a:srgbClr val="1A1A2E"/>
                 </a:solidFill>
@@ -7381,8 +7346,8 @@
         </p:nvSpPr>
         <p:spPr>
           <a:xfrm>
-            <a:off x="548640" y="2743200"/>
-            <a:ext cx="10972800" cy="2286000"/>
+            <a:off x="548640" y="3108960"/>
+            <a:ext cx="10972800" cy="2377439"/>
           </a:xfrm>
           <a:prstGeom prst="rect">
             <a:avLst/>
@@ -7396,7 +7361,7 @@
           <a:lstStyle/>
           <a:p>
             <a:r>
-              <a:rPr sz="1400">
+              <a:rPr sz="1800">
                 <a:solidFill>
                   <a:srgbClr val="1A1A2E"/>
                 </a:solidFill>
@@ -7407,7 +7372,7 @@
           </a:p>
           <a:p>
             <a:r>
-              <a:rPr sz="1400">
+              <a:rPr sz="1800">
                 <a:solidFill>
                   <a:srgbClr val="1A1A2E"/>
                 </a:solidFill>
@@ -7418,7 +7383,7 @@
           </a:p>
           <a:p>
             <a:r>
-              <a:rPr sz="1400">
+              <a:rPr sz="1800">
                 <a:solidFill>
                   <a:srgbClr val="1A1A2E"/>
                 </a:solidFill>
@@ -7437,7 +7402,42 @@
         </p:nvSpPr>
         <p:spPr>
           <a:xfrm>
-            <a:off x="11247120" y="6446520"/>
+            <a:off x="457200" y="6492240"/>
+            <a:ext cx="9601200" cy="320040"/>
+          </a:xfrm>
+          <a:prstGeom prst="rect">
+            <a:avLst/>
+          </a:prstGeom>
+          <a:noFill/>
+        </p:spPr>
+        <p:txBody>
+          <a:bodyPr wrap="square" lIns="45720" rIns="45720" tIns="27432" bIns="27432">
+            <a:spAutoFit/>
+          </a:bodyPr>
+          <a:lstStyle/>
+          <a:p>
+            <a:pPr algn="l"/>
+            <a:r>
+              <a:rPr sz="1000" b="0">
+                <a:solidFill>
+                  <a:srgbClr val="7A8A9A"/>
+                </a:solidFill>
+                <a:latin typeface="Yu Gothic"/>
+              </a:rPr>
+              <a:t>藪医者の学び / 2026-04-09 / WHOシステム思考</a:t>
+            </a:r>
+          </a:p>
+        </p:txBody>
+      </p:sp>
+      <p:sp>
+        <p:nvSpPr>
+          <p:cNvPr id="7" name="TextBox 6"/>
+          <p:cNvSpPr txBox="1"/>
+          <p:nvPr/>
+        </p:nvSpPr>
+        <p:spPr>
+          <a:xfrm>
+            <a:off x="11247120" y="6492240"/>
             <a:ext cx="914400" cy="320040"/>
           </a:xfrm>
           <a:prstGeom prst="rect">
@@ -7453,48 +7453,13 @@
           <a:p>
             <a:pPr algn="r"/>
             <a:r>
-              <a:rPr sz="900" b="0">
+              <a:rPr sz="1000" b="0">
                 <a:solidFill>
                   <a:srgbClr val="7A8A9A"/>
                 </a:solidFill>
                 <a:latin typeface="Yu Gothic"/>
               </a:rPr>
               <a:t>23 / 28</a:t>
-            </a:r>
-          </a:p>
-        </p:txBody>
-      </p:sp>
-      <p:sp>
-        <p:nvSpPr>
-          <p:cNvPr id="7" name="TextBox 6"/>
-          <p:cNvSpPr txBox="1"/>
-          <p:nvPr/>
-        </p:nvSpPr>
-        <p:spPr>
-          <a:xfrm>
-            <a:off x="457200" y="6446520"/>
-            <a:ext cx="7315200" cy="320040"/>
-          </a:xfrm>
-          <a:prstGeom prst="rect">
-            <a:avLst/>
-          </a:prstGeom>
-          <a:noFill/>
-        </p:spPr>
-        <p:txBody>
-          <a:bodyPr wrap="square" lIns="45720" rIns="45720" tIns="27432" bIns="27432">
-            <a:spAutoFit/>
-          </a:bodyPr>
-          <a:lstStyle/>
-          <a:p>
-            <a:pPr algn="l"/>
-            <a:r>
-              <a:rPr sz="900" b="0">
-                <a:solidFill>
-                  <a:srgbClr val="7A8A9A"/>
-                </a:solidFill>
-                <a:latin typeface="Yu Gothic"/>
-              </a:rPr>
-              <a:t>家庭医療科 勉強会 / 2026-04-09</a:t>
             </a:r>
           </a:p>
         </p:txBody>
@@ -7577,7 +7542,7 @@
         <p:spPr>
           <a:xfrm>
             <a:off x="457200" y="365760"/>
-            <a:ext cx="11430000" cy="822960"/>
+            <a:ext cx="11430000" cy="914400"/>
           </a:xfrm>
           <a:prstGeom prst="rect">
             <a:avLst/>
@@ -7592,7 +7557,7 @@
           <a:p>
             <a:pPr algn="l"/>
             <a:r>
-              <a:rPr sz="2600" b="1">
+              <a:rPr sz="3000" b="1">
                 <a:solidFill>
                   <a:srgbClr val="0D2B3E"/>
                 </a:solidFill>
@@ -7611,8 +7576,8 @@
         </p:nvSpPr>
         <p:spPr>
           <a:xfrm>
-            <a:off x="548640" y="1371600"/>
-            <a:ext cx="10972800" cy="3200400"/>
+            <a:off x="548640" y="1463040"/>
+            <a:ext cx="10972800" cy="3566160"/>
           </a:xfrm>
           <a:prstGeom prst="rect">
             <a:avLst/>
@@ -7627,7 +7592,7 @@
           <a:p>
             <a:pPr algn="l"/>
             <a:r>
-              <a:rPr sz="1400" b="0">
+              <a:rPr sz="1800" b="0">
                 <a:solidFill>
                   <a:srgbClr val="1A1A2E"/>
                 </a:solidFill>
@@ -7637,7 +7602,7 @@
             </a:r>
             <a:br/>
             <a:r>
-              <a:rPr sz="1400" b="0">
+              <a:rPr sz="1800" b="0">
                 <a:solidFill>
                   <a:srgbClr val="1A1A2E"/>
                 </a:solidFill>
@@ -7647,7 +7612,7 @@
             </a:r>
             <a:br/>
             <a:r>
-              <a:rPr sz="1400" b="0">
+              <a:rPr sz="1800" b="0">
                 <a:solidFill>
                   <a:srgbClr val="1A1A2E"/>
                 </a:solidFill>
@@ -7657,7 +7622,7 @@
             </a:r>
             <a:br/>
             <a:r>
-              <a:rPr sz="1400" b="0">
+              <a:rPr sz="1800" b="0">
                 <a:solidFill>
                   <a:srgbClr val="1A1A2E"/>
                 </a:solidFill>
@@ -7667,7 +7632,7 @@
             </a:r>
             <a:br/>
             <a:r>
-              <a:rPr sz="1400" b="0">
+              <a:rPr sz="1800" b="0">
                 <a:solidFill>
                   <a:srgbClr val="1A1A2E"/>
                 </a:solidFill>
@@ -7677,7 +7642,7 @@
             </a:r>
             <a:br/>
             <a:r>
-              <a:rPr sz="1400" b="0">
+              <a:rPr sz="1800" b="0">
                 <a:solidFill>
                   <a:srgbClr val="1A1A2E"/>
                 </a:solidFill>
@@ -7696,7 +7661,42 @@
         </p:nvSpPr>
         <p:spPr>
           <a:xfrm>
-            <a:off x="11247120" y="6446520"/>
+            <a:off x="457200" y="6492240"/>
+            <a:ext cx="9601200" cy="320040"/>
+          </a:xfrm>
+          <a:prstGeom prst="rect">
+            <a:avLst/>
+          </a:prstGeom>
+          <a:noFill/>
+        </p:spPr>
+        <p:txBody>
+          <a:bodyPr wrap="square" lIns="45720" rIns="45720" tIns="27432" bIns="27432">
+            <a:spAutoFit/>
+          </a:bodyPr>
+          <a:lstStyle/>
+          <a:p>
+            <a:pPr algn="l"/>
+            <a:r>
+              <a:rPr sz="1000" b="0">
+                <a:solidFill>
+                  <a:srgbClr val="7A8A9A"/>
+                </a:solidFill>
+                <a:latin typeface="Yu Gothic"/>
+              </a:rPr>
+              <a:t>藪医者の学び / 2026-04-09 / WHOシステム思考</a:t>
+            </a:r>
+          </a:p>
+        </p:txBody>
+      </p:sp>
+      <p:sp>
+        <p:nvSpPr>
+          <p:cNvPr id="6" name="TextBox 5"/>
+          <p:cNvSpPr txBox="1"/>
+          <p:nvPr/>
+        </p:nvSpPr>
+        <p:spPr>
+          <a:xfrm>
+            <a:off x="11247120" y="6492240"/>
             <a:ext cx="914400" cy="320040"/>
           </a:xfrm>
           <a:prstGeom prst="rect">
@@ -7712,48 +7712,13 @@
           <a:p>
             <a:pPr algn="r"/>
             <a:r>
-              <a:rPr sz="900" b="0">
+              <a:rPr sz="1000" b="0">
                 <a:solidFill>
                   <a:srgbClr val="7A8A9A"/>
                 </a:solidFill>
                 <a:latin typeface="Yu Gothic"/>
               </a:rPr>
               <a:t>24 / 28</a:t>
-            </a:r>
-          </a:p>
-        </p:txBody>
-      </p:sp>
-      <p:sp>
-        <p:nvSpPr>
-          <p:cNvPr id="6" name="TextBox 5"/>
-          <p:cNvSpPr txBox="1"/>
-          <p:nvPr/>
-        </p:nvSpPr>
-        <p:spPr>
-          <a:xfrm>
-            <a:off x="457200" y="6446520"/>
-            <a:ext cx="7315200" cy="320040"/>
-          </a:xfrm>
-          <a:prstGeom prst="rect">
-            <a:avLst/>
-          </a:prstGeom>
-          <a:noFill/>
-        </p:spPr>
-        <p:txBody>
-          <a:bodyPr wrap="square" lIns="45720" rIns="45720" tIns="27432" bIns="27432">
-            <a:spAutoFit/>
-          </a:bodyPr>
-          <a:lstStyle/>
-          <a:p>
-            <a:pPr algn="l"/>
-            <a:r>
-              <a:rPr sz="900" b="0">
-                <a:solidFill>
-                  <a:srgbClr val="7A8A9A"/>
-                </a:solidFill>
-                <a:latin typeface="Yu Gothic"/>
-              </a:rPr>
-              <a:t>家庭医療科 勉強会 / 2026-04-09</a:t>
             </a:r>
           </a:p>
         </p:txBody>
@@ -7836,7 +7801,7 @@
         <p:spPr>
           <a:xfrm>
             <a:off x="457200" y="365760"/>
-            <a:ext cx="11430000" cy="822960"/>
+            <a:ext cx="11430000" cy="914400"/>
           </a:xfrm>
           <a:prstGeom prst="rect">
             <a:avLst/>
@@ -7851,7 +7816,7 @@
           <a:p>
             <a:pPr algn="l"/>
             <a:r>
-              <a:rPr sz="2600" b="1">
+              <a:rPr sz="3000" b="1">
                 <a:solidFill>
                   <a:srgbClr val="0D2B3E"/>
                 </a:solidFill>
@@ -7870,8 +7835,8 @@
         </p:nvSpPr>
         <p:spPr>
           <a:xfrm>
-            <a:off x="548640" y="1371600"/>
-            <a:ext cx="10972800" cy="3200400"/>
+            <a:off x="548640" y="1463040"/>
+            <a:ext cx="10972800" cy="3566160"/>
           </a:xfrm>
           <a:prstGeom prst="rect">
             <a:avLst/>
@@ -7886,7 +7851,7 @@
           <a:p>
             <a:pPr algn="l"/>
             <a:r>
-              <a:rPr sz="1400" b="0">
+              <a:rPr sz="1800" b="0">
                 <a:solidFill>
                   <a:srgbClr val="1A1A2E"/>
                 </a:solidFill>
@@ -7905,8 +7870,8 @@
         </p:nvSpPr>
         <p:spPr>
           <a:xfrm>
-            <a:off x="548640" y="2743200"/>
-            <a:ext cx="10972800" cy="2286000"/>
+            <a:off x="548640" y="3108960"/>
+            <a:ext cx="10972800" cy="2377439"/>
           </a:xfrm>
           <a:prstGeom prst="rect">
             <a:avLst/>
@@ -7920,7 +7885,7 @@
           <a:lstStyle/>
           <a:p>
             <a:r>
-              <a:rPr sz="1400">
+              <a:rPr sz="1800">
                 <a:solidFill>
                   <a:srgbClr val="1A1A2E"/>
                 </a:solidFill>
@@ -7931,7 +7896,7 @@
           </a:p>
           <a:p>
             <a:r>
-              <a:rPr sz="1400">
+              <a:rPr sz="1800">
                 <a:solidFill>
                   <a:srgbClr val="1A1A2E"/>
                 </a:solidFill>
@@ -7942,7 +7907,7 @@
           </a:p>
           <a:p>
             <a:r>
-              <a:rPr sz="1400">
+              <a:rPr sz="1800">
                 <a:solidFill>
                   <a:srgbClr val="1A1A2E"/>
                 </a:solidFill>
@@ -7961,7 +7926,42 @@
         </p:nvSpPr>
         <p:spPr>
           <a:xfrm>
-            <a:off x="11247120" y="6446520"/>
+            <a:off x="457200" y="6492240"/>
+            <a:ext cx="9601200" cy="320040"/>
+          </a:xfrm>
+          <a:prstGeom prst="rect">
+            <a:avLst/>
+          </a:prstGeom>
+          <a:noFill/>
+        </p:spPr>
+        <p:txBody>
+          <a:bodyPr wrap="square" lIns="45720" rIns="45720" tIns="27432" bIns="27432">
+            <a:spAutoFit/>
+          </a:bodyPr>
+          <a:lstStyle/>
+          <a:p>
+            <a:pPr algn="l"/>
+            <a:r>
+              <a:rPr sz="1000" b="0">
+                <a:solidFill>
+                  <a:srgbClr val="7A8A9A"/>
+                </a:solidFill>
+                <a:latin typeface="Yu Gothic"/>
+              </a:rPr>
+              <a:t>藪医者の学び / 2026-04-09 / WHOシステム思考</a:t>
+            </a:r>
+          </a:p>
+        </p:txBody>
+      </p:sp>
+      <p:sp>
+        <p:nvSpPr>
+          <p:cNvPr id="7" name="TextBox 6"/>
+          <p:cNvSpPr txBox="1"/>
+          <p:nvPr/>
+        </p:nvSpPr>
+        <p:spPr>
+          <a:xfrm>
+            <a:off x="11247120" y="6492240"/>
             <a:ext cx="914400" cy="320040"/>
           </a:xfrm>
           <a:prstGeom prst="rect">
@@ -7977,48 +7977,13 @@
           <a:p>
             <a:pPr algn="r"/>
             <a:r>
-              <a:rPr sz="900" b="0">
+              <a:rPr sz="1000" b="0">
                 <a:solidFill>
                   <a:srgbClr val="7A8A9A"/>
                 </a:solidFill>
                 <a:latin typeface="Yu Gothic"/>
               </a:rPr>
               <a:t>25 / 28</a:t>
-            </a:r>
-          </a:p>
-        </p:txBody>
-      </p:sp>
-      <p:sp>
-        <p:nvSpPr>
-          <p:cNvPr id="7" name="TextBox 6"/>
-          <p:cNvSpPr txBox="1"/>
-          <p:nvPr/>
-        </p:nvSpPr>
-        <p:spPr>
-          <a:xfrm>
-            <a:off x="457200" y="6446520"/>
-            <a:ext cx="7315200" cy="320040"/>
-          </a:xfrm>
-          <a:prstGeom prst="rect">
-            <a:avLst/>
-          </a:prstGeom>
-          <a:noFill/>
-        </p:spPr>
-        <p:txBody>
-          <a:bodyPr wrap="square" lIns="45720" rIns="45720" tIns="27432" bIns="27432">
-            <a:spAutoFit/>
-          </a:bodyPr>
-          <a:lstStyle/>
-          <a:p>
-            <a:pPr algn="l"/>
-            <a:r>
-              <a:rPr sz="900" b="0">
-                <a:solidFill>
-                  <a:srgbClr val="7A8A9A"/>
-                </a:solidFill>
-                <a:latin typeface="Yu Gothic"/>
-              </a:rPr>
-              <a:t>家庭医療科 勉強会 / 2026-04-09</a:t>
             </a:r>
           </a:p>
         </p:txBody>
@@ -8101,7 +8066,7 @@
         <p:spPr>
           <a:xfrm>
             <a:off x="457200" y="365760"/>
-            <a:ext cx="11430000" cy="822960"/>
+            <a:ext cx="11430000" cy="914400"/>
           </a:xfrm>
           <a:prstGeom prst="rect">
             <a:avLst/>
@@ -8116,7 +8081,7 @@
           <a:p>
             <a:pPr algn="l"/>
             <a:r>
-              <a:rPr sz="2600" b="1">
+              <a:rPr sz="3000" b="1">
                 <a:solidFill>
                   <a:srgbClr val="0D2B3E"/>
                 </a:solidFill>
@@ -8135,8 +8100,8 @@
         </p:nvSpPr>
         <p:spPr>
           <a:xfrm>
-            <a:off x="548640" y="1371600"/>
-            <a:ext cx="10972800" cy="3200400"/>
+            <a:off x="548640" y="1463040"/>
+            <a:ext cx="10972800" cy="3566160"/>
           </a:xfrm>
           <a:prstGeom prst="rect">
             <a:avLst/>
@@ -8151,7 +8116,7 @@
           <a:p>
             <a:pPr algn="l"/>
             <a:r>
-              <a:rPr sz="1400" b="0">
+              <a:rPr sz="1800" b="0">
                 <a:solidFill>
                   <a:srgbClr val="1A1A2E"/>
                 </a:solidFill>
@@ -8161,7 +8126,7 @@
             </a:r>
             <a:br/>
             <a:r>
-              <a:rPr sz="1400" b="0">
+              <a:rPr sz="1800" b="0">
                 <a:solidFill>
                   <a:srgbClr val="1A1A2E"/>
                 </a:solidFill>
@@ -8180,8 +8145,8 @@
         </p:nvSpPr>
         <p:spPr>
           <a:xfrm>
-            <a:off x="548640" y="2743200"/>
-            <a:ext cx="10972800" cy="2286000"/>
+            <a:off x="548640" y="3108960"/>
+            <a:ext cx="10972800" cy="2377439"/>
           </a:xfrm>
           <a:prstGeom prst="rect">
             <a:avLst/>
@@ -8195,7 +8160,7 @@
           <a:lstStyle/>
           <a:p>
             <a:r>
-              <a:rPr sz="1400">
+              <a:rPr sz="1800">
                 <a:solidFill>
                   <a:srgbClr val="1A1A2E"/>
                 </a:solidFill>
@@ -8206,7 +8171,7 @@
           </a:p>
           <a:p>
             <a:r>
-              <a:rPr sz="1400">
+              <a:rPr sz="1800">
                 <a:solidFill>
                   <a:srgbClr val="1A1A2E"/>
                 </a:solidFill>
@@ -8217,7 +8182,7 @@
           </a:p>
           <a:p>
             <a:r>
-              <a:rPr sz="1400">
+              <a:rPr sz="1800">
                 <a:solidFill>
                   <a:srgbClr val="1A1A2E"/>
                 </a:solidFill>
@@ -8236,7 +8201,42 @@
         </p:nvSpPr>
         <p:spPr>
           <a:xfrm>
-            <a:off x="11247120" y="6446520"/>
+            <a:off x="457200" y="6492240"/>
+            <a:ext cx="9601200" cy="320040"/>
+          </a:xfrm>
+          <a:prstGeom prst="rect">
+            <a:avLst/>
+          </a:prstGeom>
+          <a:noFill/>
+        </p:spPr>
+        <p:txBody>
+          <a:bodyPr wrap="square" lIns="45720" rIns="45720" tIns="27432" bIns="27432">
+            <a:spAutoFit/>
+          </a:bodyPr>
+          <a:lstStyle/>
+          <a:p>
+            <a:pPr algn="l"/>
+            <a:r>
+              <a:rPr sz="1000" b="0">
+                <a:solidFill>
+                  <a:srgbClr val="7A8A9A"/>
+                </a:solidFill>
+                <a:latin typeface="Yu Gothic"/>
+              </a:rPr>
+              <a:t>藪医者の学び / 2026-04-09 / WHOシステム思考</a:t>
+            </a:r>
+          </a:p>
+        </p:txBody>
+      </p:sp>
+      <p:sp>
+        <p:nvSpPr>
+          <p:cNvPr id="7" name="TextBox 6"/>
+          <p:cNvSpPr txBox="1"/>
+          <p:nvPr/>
+        </p:nvSpPr>
+        <p:spPr>
+          <a:xfrm>
+            <a:off x="11247120" y="6492240"/>
             <a:ext cx="914400" cy="320040"/>
           </a:xfrm>
           <a:prstGeom prst="rect">
@@ -8252,48 +8252,13 @@
           <a:p>
             <a:pPr algn="r"/>
             <a:r>
-              <a:rPr sz="900" b="0">
+              <a:rPr sz="1000" b="0">
                 <a:solidFill>
                   <a:srgbClr val="7A8A9A"/>
                 </a:solidFill>
                 <a:latin typeface="Yu Gothic"/>
               </a:rPr>
               <a:t>26 / 28</a:t>
-            </a:r>
-          </a:p>
-        </p:txBody>
-      </p:sp>
-      <p:sp>
-        <p:nvSpPr>
-          <p:cNvPr id="7" name="TextBox 6"/>
-          <p:cNvSpPr txBox="1"/>
-          <p:nvPr/>
-        </p:nvSpPr>
-        <p:spPr>
-          <a:xfrm>
-            <a:off x="457200" y="6446520"/>
-            <a:ext cx="7315200" cy="320040"/>
-          </a:xfrm>
-          <a:prstGeom prst="rect">
-            <a:avLst/>
-          </a:prstGeom>
-          <a:noFill/>
-        </p:spPr>
-        <p:txBody>
-          <a:bodyPr wrap="square" lIns="45720" rIns="45720" tIns="27432" bIns="27432">
-            <a:spAutoFit/>
-          </a:bodyPr>
-          <a:lstStyle/>
-          <a:p>
-            <a:pPr algn="l"/>
-            <a:r>
-              <a:rPr sz="900" b="0">
-                <a:solidFill>
-                  <a:srgbClr val="7A8A9A"/>
-                </a:solidFill>
-                <a:latin typeface="Yu Gothic"/>
-              </a:rPr>
-              <a:t>家庭医療科 勉強会 / 2026-04-09</a:t>
             </a:r>
           </a:p>
         </p:txBody>
@@ -8376,7 +8341,7 @@
         <p:spPr>
           <a:xfrm>
             <a:off x="457200" y="365760"/>
-            <a:ext cx="11430000" cy="822960"/>
+            <a:ext cx="11430000" cy="914400"/>
           </a:xfrm>
           <a:prstGeom prst="rect">
             <a:avLst/>
@@ -8391,7 +8356,7 @@
           <a:p>
             <a:pPr algn="l"/>
             <a:r>
-              <a:rPr sz="2600" b="1">
+              <a:rPr sz="3000" b="1">
                 <a:solidFill>
                   <a:srgbClr val="0D2B3E"/>
                 </a:solidFill>
@@ -8410,8 +8375,8 @@
         </p:nvSpPr>
         <p:spPr>
           <a:xfrm>
-            <a:off x="548640" y="1371600"/>
-            <a:ext cx="10972800" cy="3200400"/>
+            <a:off x="548640" y="1463040"/>
+            <a:ext cx="10972800" cy="3566160"/>
           </a:xfrm>
           <a:prstGeom prst="rect">
             <a:avLst/>
@@ -8426,7 +8391,7 @@
           <a:p>
             <a:pPr algn="l"/>
             <a:r>
-              <a:rPr sz="1400" b="0">
+              <a:rPr sz="1800" b="0">
                 <a:solidFill>
                   <a:srgbClr val="1A1A2E"/>
                 </a:solidFill>
@@ -8445,8 +8410,8 @@
         </p:nvSpPr>
         <p:spPr>
           <a:xfrm>
-            <a:off x="548640" y="2743200"/>
-            <a:ext cx="10972800" cy="2286000"/>
+            <a:off x="548640" y="3108960"/>
+            <a:ext cx="10972800" cy="2377439"/>
           </a:xfrm>
           <a:prstGeom prst="rect">
             <a:avLst/>
@@ -8460,7 +8425,7 @@
           <a:lstStyle/>
           <a:p>
             <a:r>
-              <a:rPr sz="1400">
+              <a:rPr sz="1800">
                 <a:solidFill>
                   <a:srgbClr val="1A1A2E"/>
                 </a:solidFill>
@@ -8471,7 +8436,7 @@
           </a:p>
           <a:p>
             <a:r>
-              <a:rPr sz="1400">
+              <a:rPr sz="1800">
                 <a:solidFill>
                   <a:srgbClr val="1A1A2E"/>
                 </a:solidFill>
@@ -8482,7 +8447,7 @@
           </a:p>
           <a:p>
             <a:r>
-              <a:rPr sz="1400">
+              <a:rPr sz="1800">
                 <a:solidFill>
                   <a:srgbClr val="1A1A2E"/>
                 </a:solidFill>
@@ -8493,7 +8458,7 @@
           </a:p>
           <a:p>
             <a:r>
-              <a:rPr sz="1400">
+              <a:rPr sz="1800">
                 <a:solidFill>
                   <a:srgbClr val="1A1A2E"/>
                 </a:solidFill>
@@ -8512,7 +8477,42 @@
         </p:nvSpPr>
         <p:spPr>
           <a:xfrm>
-            <a:off x="11247120" y="6446520"/>
+            <a:off x="457200" y="6492240"/>
+            <a:ext cx="9601200" cy="320040"/>
+          </a:xfrm>
+          <a:prstGeom prst="rect">
+            <a:avLst/>
+          </a:prstGeom>
+          <a:noFill/>
+        </p:spPr>
+        <p:txBody>
+          <a:bodyPr wrap="square" lIns="45720" rIns="45720" tIns="27432" bIns="27432">
+            <a:spAutoFit/>
+          </a:bodyPr>
+          <a:lstStyle/>
+          <a:p>
+            <a:pPr algn="l"/>
+            <a:r>
+              <a:rPr sz="1000" b="0">
+                <a:solidFill>
+                  <a:srgbClr val="7A8A9A"/>
+                </a:solidFill>
+                <a:latin typeface="Yu Gothic"/>
+              </a:rPr>
+              <a:t>藪医者の学び / 2026-04-09 / WHOシステム思考</a:t>
+            </a:r>
+          </a:p>
+        </p:txBody>
+      </p:sp>
+      <p:sp>
+        <p:nvSpPr>
+          <p:cNvPr id="7" name="TextBox 6"/>
+          <p:cNvSpPr txBox="1"/>
+          <p:nvPr/>
+        </p:nvSpPr>
+        <p:spPr>
+          <a:xfrm>
+            <a:off x="11247120" y="6492240"/>
             <a:ext cx="914400" cy="320040"/>
           </a:xfrm>
           <a:prstGeom prst="rect">
@@ -8528,48 +8528,13 @@
           <a:p>
             <a:pPr algn="r"/>
             <a:r>
-              <a:rPr sz="900" b="0">
+              <a:rPr sz="1000" b="0">
                 <a:solidFill>
                   <a:srgbClr val="7A8A9A"/>
                 </a:solidFill>
                 <a:latin typeface="Yu Gothic"/>
               </a:rPr>
               <a:t>27 / 28</a:t>
-            </a:r>
-          </a:p>
-        </p:txBody>
-      </p:sp>
-      <p:sp>
-        <p:nvSpPr>
-          <p:cNvPr id="7" name="TextBox 6"/>
-          <p:cNvSpPr txBox="1"/>
-          <p:nvPr/>
-        </p:nvSpPr>
-        <p:spPr>
-          <a:xfrm>
-            <a:off x="457200" y="6446520"/>
-            <a:ext cx="7315200" cy="320040"/>
-          </a:xfrm>
-          <a:prstGeom prst="rect">
-            <a:avLst/>
-          </a:prstGeom>
-          <a:noFill/>
-        </p:spPr>
-        <p:txBody>
-          <a:bodyPr wrap="square" lIns="45720" rIns="45720" tIns="27432" bIns="27432">
-            <a:spAutoFit/>
-          </a:bodyPr>
-          <a:lstStyle/>
-          <a:p>
-            <a:pPr algn="l"/>
-            <a:r>
-              <a:rPr sz="900" b="0">
-                <a:solidFill>
-                  <a:srgbClr val="7A8A9A"/>
-                </a:solidFill>
-                <a:latin typeface="Yu Gothic"/>
-              </a:rPr>
-              <a:t>家庭医療科 勉強会 / 2026-04-09</a:t>
             </a:r>
           </a:p>
         </p:txBody>
@@ -8651,8 +8616,8 @@
         </p:nvSpPr>
         <p:spPr>
           <a:xfrm>
-            <a:off x="548640" y="1371600"/>
-            <a:ext cx="10972800" cy="3200400"/>
+            <a:off x="548640" y="1463040"/>
+            <a:ext cx="10972800" cy="3566160"/>
           </a:xfrm>
           <a:prstGeom prst="rect">
             <a:avLst/>
@@ -8667,7 +8632,7 @@
           <a:p>
             <a:pPr algn="l"/>
             <a:r>
-              <a:rPr sz="1400" b="0">
+              <a:rPr sz="1800" b="0">
                 <a:solidFill>
                   <a:srgbClr val="1A1A2E"/>
                 </a:solidFill>
@@ -8686,7 +8651,42 @@
         </p:nvSpPr>
         <p:spPr>
           <a:xfrm>
-            <a:off x="11247120" y="6446520"/>
+            <a:off x="457200" y="6492240"/>
+            <a:ext cx="9601200" cy="320040"/>
+          </a:xfrm>
+          <a:prstGeom prst="rect">
+            <a:avLst/>
+          </a:prstGeom>
+          <a:noFill/>
+        </p:spPr>
+        <p:txBody>
+          <a:bodyPr wrap="square" lIns="45720" rIns="45720" tIns="27432" bIns="27432">
+            <a:spAutoFit/>
+          </a:bodyPr>
+          <a:lstStyle/>
+          <a:p>
+            <a:pPr algn="l"/>
+            <a:r>
+              <a:rPr sz="1000" b="0">
+                <a:solidFill>
+                  <a:srgbClr val="7A8A9A"/>
+                </a:solidFill>
+                <a:latin typeface="Yu Gothic"/>
+              </a:rPr>
+              <a:t>藪医者の学び / 2026-04-09 / WHOシステム思考</a:t>
+            </a:r>
+          </a:p>
+        </p:txBody>
+      </p:sp>
+      <p:sp>
+        <p:nvSpPr>
+          <p:cNvPr id="5" name="TextBox 4"/>
+          <p:cNvSpPr txBox="1"/>
+          <p:nvPr/>
+        </p:nvSpPr>
+        <p:spPr>
+          <a:xfrm>
+            <a:off x="11247120" y="6492240"/>
             <a:ext cx="914400" cy="320040"/>
           </a:xfrm>
           <a:prstGeom prst="rect">
@@ -8702,48 +8702,13 @@
           <a:p>
             <a:pPr algn="r"/>
             <a:r>
-              <a:rPr sz="900" b="0">
+              <a:rPr sz="1000" b="0">
                 <a:solidFill>
                   <a:srgbClr val="7A8A9A"/>
                 </a:solidFill>
                 <a:latin typeface="Yu Gothic"/>
               </a:rPr>
               <a:t>28 / 28</a:t>
-            </a:r>
-          </a:p>
-        </p:txBody>
-      </p:sp>
-      <p:sp>
-        <p:nvSpPr>
-          <p:cNvPr id="5" name="TextBox 4"/>
-          <p:cNvSpPr txBox="1"/>
-          <p:nvPr/>
-        </p:nvSpPr>
-        <p:spPr>
-          <a:xfrm>
-            <a:off x="457200" y="6446520"/>
-            <a:ext cx="7315200" cy="320040"/>
-          </a:xfrm>
-          <a:prstGeom prst="rect">
-            <a:avLst/>
-          </a:prstGeom>
-          <a:noFill/>
-        </p:spPr>
-        <p:txBody>
-          <a:bodyPr wrap="square" lIns="45720" rIns="45720" tIns="27432" bIns="27432">
-            <a:spAutoFit/>
-          </a:bodyPr>
-          <a:lstStyle/>
-          <a:p>
-            <a:pPr algn="l"/>
-            <a:r>
-              <a:rPr sz="900" b="0">
-                <a:solidFill>
-                  <a:srgbClr val="7A8A9A"/>
-                </a:solidFill>
-                <a:latin typeface="Yu Gothic"/>
-              </a:rPr>
-              <a:t>家庭医療科 勉強会 / 2026-04-09</a:t>
             </a:r>
           </a:p>
         </p:txBody>
@@ -8764,8 +8729,8 @@
         </p:blipFill>
         <p:spPr>
           <a:xfrm>
-            <a:off x="10424160" y="5212080"/>
-            <a:ext cx="1280160" cy="1280160"/>
+            <a:off x="10424160" y="5120640"/>
+            <a:ext cx="1371600" cy="1371600"/>
           </a:xfrm>
           <a:prstGeom prst="rect">
             <a:avLst/>
@@ -8780,7 +8745,7 @@
         </p:nvSpPr>
         <p:spPr>
           <a:xfrm>
-            <a:off x="10424160" y="4983480"/>
+            <a:off x="10424160" y="4892040"/>
             <a:ext cx="1463040" cy="228600"/>
           </a:xfrm>
           <a:prstGeom prst="rect">
@@ -8796,7 +8761,7 @@
           <a:p>
             <a:pPr algn="l"/>
             <a:r>
-              <a:rPr sz="800" b="1">
+              <a:rPr sz="900" b="1">
                 <a:solidFill>
                   <a:srgbClr val="1A1A2E"/>
                 </a:solidFill>
@@ -8885,7 +8850,7 @@
         <p:spPr>
           <a:xfrm>
             <a:off x="457200" y="365760"/>
-            <a:ext cx="11430000" cy="822960"/>
+            <a:ext cx="11430000" cy="914400"/>
           </a:xfrm>
           <a:prstGeom prst="rect">
             <a:avLst/>
@@ -8900,7 +8865,7 @@
           <a:p>
             <a:pPr algn="l"/>
             <a:r>
-              <a:rPr sz="2600" b="1">
+              <a:rPr sz="3000" b="1">
                 <a:solidFill>
                   <a:srgbClr val="0D2B3E"/>
                 </a:solidFill>
@@ -8919,8 +8884,8 @@
         </p:nvSpPr>
         <p:spPr>
           <a:xfrm>
-            <a:off x="548640" y="1371600"/>
-            <a:ext cx="10972800" cy="3657600"/>
+            <a:off x="548640" y="1463040"/>
+            <a:ext cx="10972800" cy="4023360"/>
           </a:xfrm>
           <a:prstGeom prst="rect">
             <a:avLst/>
@@ -8934,7 +8899,7 @@
           <a:lstStyle/>
           <a:p>
             <a:r>
-              <a:rPr sz="1400">
+              <a:rPr sz="1800">
                 <a:solidFill>
                   <a:srgbClr val="1A1A2E"/>
                 </a:solidFill>
@@ -8945,7 +8910,7 @@
           </a:p>
           <a:p>
             <a:r>
-              <a:rPr sz="1400">
+              <a:rPr sz="1800">
                 <a:solidFill>
                   <a:srgbClr val="1A1A2E"/>
                 </a:solidFill>
@@ -8956,7 +8921,7 @@
           </a:p>
           <a:p>
             <a:r>
-              <a:rPr sz="1400">
+              <a:rPr sz="1800">
                 <a:solidFill>
                   <a:srgbClr val="1A1A2E"/>
                 </a:solidFill>
@@ -8967,7 +8932,7 @@
           </a:p>
           <a:p>
             <a:r>
-              <a:rPr sz="1400">
+              <a:rPr sz="1800">
                 <a:solidFill>
                   <a:srgbClr val="1A1A2E"/>
                 </a:solidFill>
@@ -8986,7 +8951,42 @@
         </p:nvSpPr>
         <p:spPr>
           <a:xfrm>
-            <a:off x="11247120" y="6446520"/>
+            <a:off x="457200" y="6492240"/>
+            <a:ext cx="9601200" cy="320040"/>
+          </a:xfrm>
+          <a:prstGeom prst="rect">
+            <a:avLst/>
+          </a:prstGeom>
+          <a:noFill/>
+        </p:spPr>
+        <p:txBody>
+          <a:bodyPr wrap="square" lIns="45720" rIns="45720" tIns="27432" bIns="27432">
+            <a:spAutoFit/>
+          </a:bodyPr>
+          <a:lstStyle/>
+          <a:p>
+            <a:pPr algn="l"/>
+            <a:r>
+              <a:rPr sz="1000" b="0">
+                <a:solidFill>
+                  <a:srgbClr val="7A8A9A"/>
+                </a:solidFill>
+                <a:latin typeface="Yu Gothic"/>
+              </a:rPr>
+              <a:t>藪医者の学び / 2026-04-09 / WHOシステム思考</a:t>
+            </a:r>
+          </a:p>
+        </p:txBody>
+      </p:sp>
+      <p:sp>
+        <p:nvSpPr>
+          <p:cNvPr id="6" name="TextBox 5"/>
+          <p:cNvSpPr txBox="1"/>
+          <p:nvPr/>
+        </p:nvSpPr>
+        <p:spPr>
+          <a:xfrm>
+            <a:off x="11247120" y="6492240"/>
             <a:ext cx="914400" cy="320040"/>
           </a:xfrm>
           <a:prstGeom prst="rect">
@@ -9002,48 +9002,13 @@
           <a:p>
             <a:pPr algn="r"/>
             <a:r>
-              <a:rPr sz="900" b="0">
+              <a:rPr sz="1000" b="0">
                 <a:solidFill>
                   <a:srgbClr val="7A8A9A"/>
                 </a:solidFill>
                 <a:latin typeface="Yu Gothic"/>
               </a:rPr>
               <a:t>3 / 28</a:t>
-            </a:r>
-          </a:p>
-        </p:txBody>
-      </p:sp>
-      <p:sp>
-        <p:nvSpPr>
-          <p:cNvPr id="6" name="TextBox 5"/>
-          <p:cNvSpPr txBox="1"/>
-          <p:nvPr/>
-        </p:nvSpPr>
-        <p:spPr>
-          <a:xfrm>
-            <a:off x="457200" y="6446520"/>
-            <a:ext cx="7315200" cy="320040"/>
-          </a:xfrm>
-          <a:prstGeom prst="rect">
-            <a:avLst/>
-          </a:prstGeom>
-          <a:noFill/>
-        </p:spPr>
-        <p:txBody>
-          <a:bodyPr wrap="square" lIns="45720" rIns="45720" tIns="27432" bIns="27432">
-            <a:spAutoFit/>
-          </a:bodyPr>
-          <a:lstStyle/>
-          <a:p>
-            <a:pPr algn="l"/>
-            <a:r>
-              <a:rPr sz="900" b="0">
-                <a:solidFill>
-                  <a:srgbClr val="7A8A9A"/>
-                </a:solidFill>
-                <a:latin typeface="Yu Gothic"/>
-              </a:rPr>
-              <a:t>家庭医療科 勉強会 / 2026-04-09</a:t>
             </a:r>
           </a:p>
         </p:txBody>
@@ -9126,7 +9091,7 @@
         <p:spPr>
           <a:xfrm>
             <a:off x="457200" y="365760"/>
-            <a:ext cx="11430000" cy="822960"/>
+            <a:ext cx="11430000" cy="914400"/>
           </a:xfrm>
           <a:prstGeom prst="rect">
             <a:avLst/>
@@ -9141,7 +9106,7 @@
           <a:p>
             <a:pPr algn="l"/>
             <a:r>
-              <a:rPr sz="2600" b="1">
+              <a:rPr sz="3000" b="1">
                 <a:solidFill>
                   <a:srgbClr val="E89B3B"/>
                 </a:solidFill>
@@ -9160,7 +9125,42 @@
         </p:nvSpPr>
         <p:spPr>
           <a:xfrm>
-            <a:off x="11247120" y="6446520"/>
+            <a:off x="457200" y="6492240"/>
+            <a:ext cx="9601200" cy="320040"/>
+          </a:xfrm>
+          <a:prstGeom prst="rect">
+            <a:avLst/>
+          </a:prstGeom>
+          <a:noFill/>
+        </p:spPr>
+        <p:txBody>
+          <a:bodyPr wrap="square" lIns="45720" rIns="45720" tIns="27432" bIns="27432">
+            <a:spAutoFit/>
+          </a:bodyPr>
+          <a:lstStyle/>
+          <a:p>
+            <a:pPr algn="l"/>
+            <a:r>
+              <a:rPr sz="1000" b="0">
+                <a:solidFill>
+                  <a:srgbClr val="7A8A9A"/>
+                </a:solidFill>
+                <a:latin typeface="Yu Gothic"/>
+              </a:rPr>
+              <a:t>藪医者の学び / 2026-04-09 / WHOシステム思考</a:t>
+            </a:r>
+          </a:p>
+        </p:txBody>
+      </p:sp>
+      <p:sp>
+        <p:nvSpPr>
+          <p:cNvPr id="5" name="TextBox 4"/>
+          <p:cNvSpPr txBox="1"/>
+          <p:nvPr/>
+        </p:nvSpPr>
+        <p:spPr>
+          <a:xfrm>
+            <a:off x="11247120" y="6492240"/>
             <a:ext cx="914400" cy="320040"/>
           </a:xfrm>
           <a:prstGeom prst="rect">
@@ -9176,48 +9176,13 @@
           <a:p>
             <a:pPr algn="r"/>
             <a:r>
-              <a:rPr sz="900" b="0">
+              <a:rPr sz="1000" b="0">
                 <a:solidFill>
                   <a:srgbClr val="7A8A9A"/>
                 </a:solidFill>
                 <a:latin typeface="Yu Gothic"/>
               </a:rPr>
               <a:t>4 / 28</a:t>
-            </a:r>
-          </a:p>
-        </p:txBody>
-      </p:sp>
-      <p:sp>
-        <p:nvSpPr>
-          <p:cNvPr id="5" name="TextBox 4"/>
-          <p:cNvSpPr txBox="1"/>
-          <p:nvPr/>
-        </p:nvSpPr>
-        <p:spPr>
-          <a:xfrm>
-            <a:off x="457200" y="6446520"/>
-            <a:ext cx="7315200" cy="320040"/>
-          </a:xfrm>
-          <a:prstGeom prst="rect">
-            <a:avLst/>
-          </a:prstGeom>
-          <a:noFill/>
-        </p:spPr>
-        <p:txBody>
-          <a:bodyPr wrap="square" lIns="45720" rIns="45720" tIns="27432" bIns="27432">
-            <a:spAutoFit/>
-          </a:bodyPr>
-          <a:lstStyle/>
-          <a:p>
-            <a:pPr algn="l"/>
-            <a:r>
-              <a:rPr sz="900" b="0">
-                <a:solidFill>
-                  <a:srgbClr val="7A8A9A"/>
-                </a:solidFill>
-                <a:latin typeface="Yu Gothic"/>
-              </a:rPr>
-              <a:t>家庭医療科 勉強会 / 2026-04-09</a:t>
             </a:r>
           </a:p>
         </p:txBody>
@@ -9300,7 +9265,7 @@
         <p:spPr>
           <a:xfrm>
             <a:off x="457200" y="365760"/>
-            <a:ext cx="11430000" cy="822960"/>
+            <a:ext cx="11430000" cy="914400"/>
           </a:xfrm>
           <a:prstGeom prst="rect">
             <a:avLst/>
@@ -9315,7 +9280,7 @@
           <a:p>
             <a:pPr algn="l"/>
             <a:r>
-              <a:rPr sz="2600" b="1">
+              <a:rPr sz="3000" b="1">
                 <a:solidFill>
                   <a:srgbClr val="0D2B3E"/>
                 </a:solidFill>
@@ -9334,8 +9299,8 @@
         </p:nvSpPr>
         <p:spPr>
           <a:xfrm>
-            <a:off x="548640" y="1371600"/>
-            <a:ext cx="10972800" cy="3200400"/>
+            <a:off x="548640" y="1463040"/>
+            <a:ext cx="10972800" cy="3566160"/>
           </a:xfrm>
           <a:prstGeom prst="rect">
             <a:avLst/>
@@ -9350,7 +9315,7 @@
           <a:p>
             <a:pPr algn="l"/>
             <a:r>
-              <a:rPr sz="1400" b="0">
+              <a:rPr sz="1800" b="0">
                 <a:solidFill>
                   <a:srgbClr val="1A1A2E"/>
                 </a:solidFill>
@@ -9369,8 +9334,8 @@
         </p:nvSpPr>
         <p:spPr>
           <a:xfrm>
-            <a:off x="548640" y="2743200"/>
-            <a:ext cx="10972800" cy="2286000"/>
+            <a:off x="548640" y="3108960"/>
+            <a:ext cx="10972800" cy="2377439"/>
           </a:xfrm>
           <a:prstGeom prst="rect">
             <a:avLst/>
@@ -9384,7 +9349,7 @@
           <a:lstStyle/>
           <a:p>
             <a:r>
-              <a:rPr sz="1400">
+              <a:rPr sz="1800">
                 <a:solidFill>
                   <a:srgbClr val="1A1A2E"/>
                 </a:solidFill>
@@ -9395,7 +9360,7 @@
           </a:p>
           <a:p>
             <a:r>
-              <a:rPr sz="1400">
+              <a:rPr sz="1800">
                 <a:solidFill>
                   <a:srgbClr val="1A1A2E"/>
                 </a:solidFill>
@@ -9406,7 +9371,7 @@
           </a:p>
           <a:p>
             <a:r>
-              <a:rPr sz="1400">
+              <a:rPr sz="1800">
                 <a:solidFill>
                   <a:srgbClr val="1A1A2E"/>
                 </a:solidFill>
@@ -9417,7 +9382,7 @@
           </a:p>
           <a:p>
             <a:r>
-              <a:rPr sz="1400">
+              <a:rPr sz="1800">
                 <a:solidFill>
                   <a:srgbClr val="1A1A2E"/>
                 </a:solidFill>
@@ -9428,7 +9393,7 @@
           </a:p>
           <a:p>
             <a:r>
-              <a:rPr sz="1400">
+              <a:rPr sz="1800">
                 <a:solidFill>
                   <a:srgbClr val="1A1A2E"/>
                 </a:solidFill>
@@ -9439,7 +9404,7 @@
           </a:p>
           <a:p>
             <a:r>
-              <a:rPr sz="1400">
+              <a:rPr sz="1800">
                 <a:solidFill>
                   <a:srgbClr val="1A1A2E"/>
                 </a:solidFill>
@@ -9458,7 +9423,42 @@
         </p:nvSpPr>
         <p:spPr>
           <a:xfrm>
-            <a:off x="11247120" y="6446520"/>
+            <a:off x="457200" y="6492240"/>
+            <a:ext cx="9601200" cy="320040"/>
+          </a:xfrm>
+          <a:prstGeom prst="rect">
+            <a:avLst/>
+          </a:prstGeom>
+          <a:noFill/>
+        </p:spPr>
+        <p:txBody>
+          <a:bodyPr wrap="square" lIns="45720" rIns="45720" tIns="27432" bIns="27432">
+            <a:spAutoFit/>
+          </a:bodyPr>
+          <a:lstStyle/>
+          <a:p>
+            <a:pPr algn="l"/>
+            <a:r>
+              <a:rPr sz="1000" b="0">
+                <a:solidFill>
+                  <a:srgbClr val="7A8A9A"/>
+                </a:solidFill>
+                <a:latin typeface="Yu Gothic"/>
+              </a:rPr>
+              <a:t>藪医者の学び / 2026-04-09 / WHOシステム思考</a:t>
+            </a:r>
+          </a:p>
+        </p:txBody>
+      </p:sp>
+      <p:sp>
+        <p:nvSpPr>
+          <p:cNvPr id="7" name="TextBox 6"/>
+          <p:cNvSpPr txBox="1"/>
+          <p:nvPr/>
+        </p:nvSpPr>
+        <p:spPr>
+          <a:xfrm>
+            <a:off x="11247120" y="6492240"/>
             <a:ext cx="914400" cy="320040"/>
           </a:xfrm>
           <a:prstGeom prst="rect">
@@ -9474,48 +9474,13 @@
           <a:p>
             <a:pPr algn="r"/>
             <a:r>
-              <a:rPr sz="900" b="0">
+              <a:rPr sz="1000" b="0">
                 <a:solidFill>
                   <a:srgbClr val="7A8A9A"/>
                 </a:solidFill>
                 <a:latin typeface="Yu Gothic"/>
               </a:rPr>
               <a:t>5 / 28</a:t>
-            </a:r>
-          </a:p>
-        </p:txBody>
-      </p:sp>
-      <p:sp>
-        <p:nvSpPr>
-          <p:cNvPr id="7" name="TextBox 6"/>
-          <p:cNvSpPr txBox="1"/>
-          <p:nvPr/>
-        </p:nvSpPr>
-        <p:spPr>
-          <a:xfrm>
-            <a:off x="457200" y="6446520"/>
-            <a:ext cx="7315200" cy="320040"/>
-          </a:xfrm>
-          <a:prstGeom prst="rect">
-            <a:avLst/>
-          </a:prstGeom>
-          <a:noFill/>
-        </p:spPr>
-        <p:txBody>
-          <a:bodyPr wrap="square" lIns="45720" rIns="45720" tIns="27432" bIns="27432">
-            <a:spAutoFit/>
-          </a:bodyPr>
-          <a:lstStyle/>
-          <a:p>
-            <a:pPr algn="l"/>
-            <a:r>
-              <a:rPr sz="900" b="0">
-                <a:solidFill>
-                  <a:srgbClr val="7A8A9A"/>
-                </a:solidFill>
-                <a:latin typeface="Yu Gothic"/>
-              </a:rPr>
-              <a:t>家庭医療科 勉強会 / 2026-04-09</a:t>
             </a:r>
           </a:p>
         </p:txBody>
@@ -9598,7 +9563,7 @@
         <p:spPr>
           <a:xfrm>
             <a:off x="457200" y="365760"/>
-            <a:ext cx="11430000" cy="822960"/>
+            <a:ext cx="11430000" cy="914400"/>
           </a:xfrm>
           <a:prstGeom prst="rect">
             <a:avLst/>
@@ -9613,7 +9578,7 @@
           <a:p>
             <a:pPr algn="l"/>
             <a:r>
-              <a:rPr sz="2600" b="1">
+              <a:rPr sz="3000" b="1">
                 <a:solidFill>
                   <a:srgbClr val="0D2B3E"/>
                 </a:solidFill>
@@ -9632,8 +9597,8 @@
         </p:nvSpPr>
         <p:spPr>
           <a:xfrm>
-            <a:off x="548640" y="1371600"/>
-            <a:ext cx="10972800" cy="3200400"/>
+            <a:off x="548640" y="1463040"/>
+            <a:ext cx="10972800" cy="3566160"/>
           </a:xfrm>
           <a:prstGeom prst="rect">
             <a:avLst/>
@@ -9648,7 +9613,7 @@
           <a:p>
             <a:pPr algn="l"/>
             <a:r>
-              <a:rPr sz="1400" b="0">
+              <a:rPr sz="1800" b="0">
                 <a:solidFill>
                   <a:srgbClr val="1A1A2E"/>
                 </a:solidFill>
@@ -9667,8 +9632,8 @@
         </p:nvSpPr>
         <p:spPr>
           <a:xfrm>
-            <a:off x="548640" y="2743200"/>
-            <a:ext cx="10972800" cy="2286000"/>
+            <a:off x="548640" y="3108960"/>
+            <a:ext cx="10972800" cy="2377439"/>
           </a:xfrm>
           <a:prstGeom prst="rect">
             <a:avLst/>
@@ -9682,7 +9647,7 @@
           <a:lstStyle/>
           <a:p>
             <a:r>
-              <a:rPr sz="1400">
+              <a:rPr sz="1800">
                 <a:solidFill>
                   <a:srgbClr val="1A1A2E"/>
                 </a:solidFill>
@@ -9693,7 +9658,7 @@
           </a:p>
           <a:p>
             <a:r>
-              <a:rPr sz="1400">
+              <a:rPr sz="1800">
                 <a:solidFill>
                   <a:srgbClr val="1A1A2E"/>
                 </a:solidFill>
@@ -9704,7 +9669,7 @@
           </a:p>
           <a:p>
             <a:r>
-              <a:rPr sz="1400">
+              <a:rPr sz="1800">
                 <a:solidFill>
                   <a:srgbClr val="1A1A2E"/>
                 </a:solidFill>
@@ -9715,7 +9680,7 @@
           </a:p>
           <a:p>
             <a:r>
-              <a:rPr sz="1400">
+              <a:rPr sz="1800">
                 <a:solidFill>
                   <a:srgbClr val="1A1A2E"/>
                 </a:solidFill>
@@ -9734,7 +9699,42 @@
         </p:nvSpPr>
         <p:spPr>
           <a:xfrm>
-            <a:off x="11247120" y="6446520"/>
+            <a:off x="457200" y="6492240"/>
+            <a:ext cx="9601200" cy="320040"/>
+          </a:xfrm>
+          <a:prstGeom prst="rect">
+            <a:avLst/>
+          </a:prstGeom>
+          <a:noFill/>
+        </p:spPr>
+        <p:txBody>
+          <a:bodyPr wrap="square" lIns="45720" rIns="45720" tIns="27432" bIns="27432">
+            <a:spAutoFit/>
+          </a:bodyPr>
+          <a:lstStyle/>
+          <a:p>
+            <a:pPr algn="l"/>
+            <a:r>
+              <a:rPr sz="1000" b="0">
+                <a:solidFill>
+                  <a:srgbClr val="7A8A9A"/>
+                </a:solidFill>
+                <a:latin typeface="Yu Gothic"/>
+              </a:rPr>
+              <a:t>藪医者の学び / 2026-04-09 / WHOシステム思考</a:t>
+            </a:r>
+          </a:p>
+        </p:txBody>
+      </p:sp>
+      <p:sp>
+        <p:nvSpPr>
+          <p:cNvPr id="7" name="TextBox 6"/>
+          <p:cNvSpPr txBox="1"/>
+          <p:nvPr/>
+        </p:nvSpPr>
+        <p:spPr>
+          <a:xfrm>
+            <a:off x="11247120" y="6492240"/>
             <a:ext cx="914400" cy="320040"/>
           </a:xfrm>
           <a:prstGeom prst="rect">
@@ -9750,48 +9750,13 @@
           <a:p>
             <a:pPr algn="r"/>
             <a:r>
-              <a:rPr sz="900" b="0">
+              <a:rPr sz="1000" b="0">
                 <a:solidFill>
                   <a:srgbClr val="7A8A9A"/>
                 </a:solidFill>
                 <a:latin typeface="Yu Gothic"/>
               </a:rPr>
               <a:t>6 / 28</a:t>
-            </a:r>
-          </a:p>
-        </p:txBody>
-      </p:sp>
-      <p:sp>
-        <p:nvSpPr>
-          <p:cNvPr id="7" name="TextBox 6"/>
-          <p:cNvSpPr txBox="1"/>
-          <p:nvPr/>
-        </p:nvSpPr>
-        <p:spPr>
-          <a:xfrm>
-            <a:off x="457200" y="6446520"/>
-            <a:ext cx="7315200" cy="320040"/>
-          </a:xfrm>
-          <a:prstGeom prst="rect">
-            <a:avLst/>
-          </a:prstGeom>
-          <a:noFill/>
-        </p:spPr>
-        <p:txBody>
-          <a:bodyPr wrap="square" lIns="45720" rIns="45720" tIns="27432" bIns="27432">
-            <a:spAutoFit/>
-          </a:bodyPr>
-          <a:lstStyle/>
-          <a:p>
-            <a:pPr algn="l"/>
-            <a:r>
-              <a:rPr sz="900" b="0">
-                <a:solidFill>
-                  <a:srgbClr val="7A8A9A"/>
-                </a:solidFill>
-                <a:latin typeface="Yu Gothic"/>
-              </a:rPr>
-              <a:t>家庭医療科 勉強会 / 2026-04-09</a:t>
             </a:r>
           </a:p>
         </p:txBody>
@@ -9874,7 +9839,7 @@
         <p:spPr>
           <a:xfrm>
             <a:off x="457200" y="365760"/>
-            <a:ext cx="11430000" cy="822960"/>
+            <a:ext cx="11430000" cy="914400"/>
           </a:xfrm>
           <a:prstGeom prst="rect">
             <a:avLst/>
@@ -9889,7 +9854,7 @@
           <a:p>
             <a:pPr algn="l"/>
             <a:r>
-              <a:rPr sz="2600" b="1">
+              <a:rPr sz="3000" b="1">
                 <a:solidFill>
                   <a:srgbClr val="0D2B3E"/>
                 </a:solidFill>
@@ -9908,8 +9873,8 @@
         </p:nvSpPr>
         <p:spPr>
           <a:xfrm>
-            <a:off x="548640" y="1371600"/>
-            <a:ext cx="10972800" cy="3200400"/>
+            <a:off x="548640" y="1463040"/>
+            <a:ext cx="10972800" cy="3566160"/>
           </a:xfrm>
           <a:prstGeom prst="rect">
             <a:avLst/>
@@ -9924,7 +9889,7 @@
           <a:p>
             <a:pPr algn="l"/>
             <a:r>
-              <a:rPr sz="1400" b="0">
+              <a:rPr sz="1800" b="0">
                 <a:solidFill>
                   <a:srgbClr val="1A1A2E"/>
                 </a:solidFill>
@@ -9934,7 +9899,7 @@
             </a:r>
             <a:br/>
             <a:r>
-              <a:rPr sz="1400" b="0">
+              <a:rPr sz="1800" b="0">
                 <a:solidFill>
                   <a:srgbClr val="1A1A2E"/>
                 </a:solidFill>
@@ -9953,8 +9918,8 @@
         </p:nvSpPr>
         <p:spPr>
           <a:xfrm>
-            <a:off x="548640" y="2743200"/>
-            <a:ext cx="10972800" cy="2286000"/>
+            <a:off x="548640" y="3108960"/>
+            <a:ext cx="10972800" cy="2377439"/>
           </a:xfrm>
           <a:prstGeom prst="rect">
             <a:avLst/>
@@ -9968,7 +9933,7 @@
           <a:lstStyle/>
           <a:p>
             <a:r>
-              <a:rPr sz="1400">
+              <a:rPr sz="1800">
                 <a:solidFill>
                   <a:srgbClr val="1A1A2E"/>
                 </a:solidFill>
@@ -9979,7 +9944,7 @@
           </a:p>
           <a:p>
             <a:r>
-              <a:rPr sz="1400">
+              <a:rPr sz="1800">
                 <a:solidFill>
                   <a:srgbClr val="1A1A2E"/>
                 </a:solidFill>
@@ -9990,7 +9955,7 @@
           </a:p>
           <a:p>
             <a:r>
-              <a:rPr sz="1400">
+              <a:rPr sz="1800">
                 <a:solidFill>
                   <a:srgbClr val="1A1A2E"/>
                 </a:solidFill>
@@ -10001,7 +9966,7 @@
           </a:p>
           <a:p>
             <a:r>
-              <a:rPr sz="1400">
+              <a:rPr sz="1800">
                 <a:solidFill>
                   <a:srgbClr val="1A1A2E"/>
                 </a:solidFill>
@@ -10012,7 +9977,7 @@
           </a:p>
           <a:p>
             <a:r>
-              <a:rPr sz="1400">
+              <a:rPr sz="1800">
                 <a:solidFill>
                   <a:srgbClr val="1A1A2E"/>
                 </a:solidFill>
@@ -10031,7 +9996,42 @@
         </p:nvSpPr>
         <p:spPr>
           <a:xfrm>
-            <a:off x="11247120" y="6446520"/>
+            <a:off x="457200" y="6492240"/>
+            <a:ext cx="9601200" cy="320040"/>
+          </a:xfrm>
+          <a:prstGeom prst="rect">
+            <a:avLst/>
+          </a:prstGeom>
+          <a:noFill/>
+        </p:spPr>
+        <p:txBody>
+          <a:bodyPr wrap="square" lIns="45720" rIns="45720" tIns="27432" bIns="27432">
+            <a:spAutoFit/>
+          </a:bodyPr>
+          <a:lstStyle/>
+          <a:p>
+            <a:pPr algn="l"/>
+            <a:r>
+              <a:rPr sz="1000" b="0">
+                <a:solidFill>
+                  <a:srgbClr val="7A8A9A"/>
+                </a:solidFill>
+                <a:latin typeface="Yu Gothic"/>
+              </a:rPr>
+              <a:t>藪医者の学び / 2026-04-09 / WHOシステム思考</a:t>
+            </a:r>
+          </a:p>
+        </p:txBody>
+      </p:sp>
+      <p:sp>
+        <p:nvSpPr>
+          <p:cNvPr id="7" name="TextBox 6"/>
+          <p:cNvSpPr txBox="1"/>
+          <p:nvPr/>
+        </p:nvSpPr>
+        <p:spPr>
+          <a:xfrm>
+            <a:off x="11247120" y="6492240"/>
             <a:ext cx="914400" cy="320040"/>
           </a:xfrm>
           <a:prstGeom prst="rect">
@@ -10047,48 +10047,13 @@
           <a:p>
             <a:pPr algn="r"/>
             <a:r>
-              <a:rPr sz="900" b="0">
+              <a:rPr sz="1000" b="0">
                 <a:solidFill>
                   <a:srgbClr val="7A8A9A"/>
                 </a:solidFill>
                 <a:latin typeface="Yu Gothic"/>
               </a:rPr>
               <a:t>7 / 28</a:t>
-            </a:r>
-          </a:p>
-        </p:txBody>
-      </p:sp>
-      <p:sp>
-        <p:nvSpPr>
-          <p:cNvPr id="7" name="TextBox 6"/>
-          <p:cNvSpPr txBox="1"/>
-          <p:nvPr/>
-        </p:nvSpPr>
-        <p:spPr>
-          <a:xfrm>
-            <a:off x="457200" y="6446520"/>
-            <a:ext cx="7315200" cy="320040"/>
-          </a:xfrm>
-          <a:prstGeom prst="rect">
-            <a:avLst/>
-          </a:prstGeom>
-          <a:noFill/>
-        </p:spPr>
-        <p:txBody>
-          <a:bodyPr wrap="square" lIns="45720" rIns="45720" tIns="27432" bIns="27432">
-            <a:spAutoFit/>
-          </a:bodyPr>
-          <a:lstStyle/>
-          <a:p>
-            <a:pPr algn="l"/>
-            <a:r>
-              <a:rPr sz="900" b="0">
-                <a:solidFill>
-                  <a:srgbClr val="7A8A9A"/>
-                </a:solidFill>
-                <a:latin typeface="Yu Gothic"/>
-              </a:rPr>
-              <a:t>家庭医療科 勉強会 / 2026-04-09</a:t>
             </a:r>
           </a:p>
         </p:txBody>
@@ -10171,7 +10136,7 @@
         <p:spPr>
           <a:xfrm>
             <a:off x="457200" y="365760"/>
-            <a:ext cx="11430000" cy="822960"/>
+            <a:ext cx="11430000" cy="914400"/>
           </a:xfrm>
           <a:prstGeom prst="rect">
             <a:avLst/>
@@ -10186,7 +10151,7 @@
           <a:p>
             <a:pPr algn="l"/>
             <a:r>
-              <a:rPr sz="2600" b="1">
+              <a:rPr sz="3000" b="1">
                 <a:solidFill>
                   <a:srgbClr val="0D2B3E"/>
                 </a:solidFill>
@@ -10205,8 +10170,8 @@
         </p:nvSpPr>
         <p:spPr>
           <a:xfrm>
-            <a:off x="548640" y="1371600"/>
-            <a:ext cx="10972800" cy="3200400"/>
+            <a:off x="548640" y="1463040"/>
+            <a:ext cx="10972800" cy="3566160"/>
           </a:xfrm>
           <a:prstGeom prst="rect">
             <a:avLst/>
@@ -10221,7 +10186,7 @@
           <a:p>
             <a:pPr algn="l"/>
             <a:r>
-              <a:rPr sz="1400" b="0">
+              <a:rPr sz="1800" b="0">
                 <a:solidFill>
                   <a:srgbClr val="1A1A2E"/>
                 </a:solidFill>
@@ -10231,7 +10196,7 @@
             </a:r>
             <a:br/>
             <a:r>
-              <a:rPr sz="1400" b="0">
+              <a:rPr sz="1800" b="0">
                 <a:solidFill>
                   <a:srgbClr val="1A1A2E"/>
                 </a:solidFill>
@@ -10241,7 +10206,7 @@
             </a:r>
             <a:br/>
             <a:r>
-              <a:rPr sz="1400" b="0">
+              <a:rPr sz="1800" b="0">
                 <a:solidFill>
                   <a:srgbClr val="1A1A2E"/>
                 </a:solidFill>
@@ -10251,7 +10216,7 @@
             </a:r>
             <a:br/>
             <a:r>
-              <a:rPr sz="1400" b="0">
+              <a:rPr sz="1800" b="0">
                 <a:solidFill>
                   <a:srgbClr val="1A1A2E"/>
                 </a:solidFill>
@@ -10270,8 +10235,8 @@
         </p:nvSpPr>
         <p:spPr>
           <a:xfrm>
-            <a:off x="548640" y="2743200"/>
-            <a:ext cx="10972800" cy="2286000"/>
+            <a:off x="548640" y="3108960"/>
+            <a:ext cx="10972800" cy="2377439"/>
           </a:xfrm>
           <a:prstGeom prst="rect">
             <a:avLst/>
@@ -10285,7 +10250,7 @@
           <a:lstStyle/>
           <a:p>
             <a:r>
-              <a:rPr sz="1400">
+              <a:rPr sz="1800">
                 <a:solidFill>
                   <a:srgbClr val="1A1A2E"/>
                 </a:solidFill>
@@ -10296,7 +10261,7 @@
           </a:p>
           <a:p>
             <a:r>
-              <a:rPr sz="1400">
+              <a:rPr sz="1800">
                 <a:solidFill>
                   <a:srgbClr val="1A1A2E"/>
                 </a:solidFill>
@@ -10307,7 +10272,7 @@
           </a:p>
           <a:p>
             <a:r>
-              <a:rPr sz="1400">
+              <a:rPr sz="1800">
                 <a:solidFill>
                   <a:srgbClr val="1A1A2E"/>
                 </a:solidFill>
@@ -10326,7 +10291,42 @@
         </p:nvSpPr>
         <p:spPr>
           <a:xfrm>
-            <a:off x="11247120" y="6446520"/>
+            <a:off x="457200" y="6492240"/>
+            <a:ext cx="9601200" cy="320040"/>
+          </a:xfrm>
+          <a:prstGeom prst="rect">
+            <a:avLst/>
+          </a:prstGeom>
+          <a:noFill/>
+        </p:spPr>
+        <p:txBody>
+          <a:bodyPr wrap="square" lIns="45720" rIns="45720" tIns="27432" bIns="27432">
+            <a:spAutoFit/>
+          </a:bodyPr>
+          <a:lstStyle/>
+          <a:p>
+            <a:pPr algn="l"/>
+            <a:r>
+              <a:rPr sz="1000" b="0">
+                <a:solidFill>
+                  <a:srgbClr val="7A8A9A"/>
+                </a:solidFill>
+                <a:latin typeface="Yu Gothic"/>
+              </a:rPr>
+              <a:t>藪医者の学び / 2026-04-09 / WHOシステム思考</a:t>
+            </a:r>
+          </a:p>
+        </p:txBody>
+      </p:sp>
+      <p:sp>
+        <p:nvSpPr>
+          <p:cNvPr id="7" name="TextBox 6"/>
+          <p:cNvSpPr txBox="1"/>
+          <p:nvPr/>
+        </p:nvSpPr>
+        <p:spPr>
+          <a:xfrm>
+            <a:off x="11247120" y="6492240"/>
             <a:ext cx="914400" cy="320040"/>
           </a:xfrm>
           <a:prstGeom prst="rect">
@@ -10342,48 +10342,13 @@
           <a:p>
             <a:pPr algn="r"/>
             <a:r>
-              <a:rPr sz="900" b="0">
+              <a:rPr sz="1000" b="0">
                 <a:solidFill>
                   <a:srgbClr val="7A8A9A"/>
                 </a:solidFill>
                 <a:latin typeface="Yu Gothic"/>
               </a:rPr>
               <a:t>8 / 28</a:t>
-            </a:r>
-          </a:p>
-        </p:txBody>
-      </p:sp>
-      <p:sp>
-        <p:nvSpPr>
-          <p:cNvPr id="7" name="TextBox 6"/>
-          <p:cNvSpPr txBox="1"/>
-          <p:nvPr/>
-        </p:nvSpPr>
-        <p:spPr>
-          <a:xfrm>
-            <a:off x="457200" y="6446520"/>
-            <a:ext cx="7315200" cy="320040"/>
-          </a:xfrm>
-          <a:prstGeom prst="rect">
-            <a:avLst/>
-          </a:prstGeom>
-          <a:noFill/>
-        </p:spPr>
-        <p:txBody>
-          <a:bodyPr wrap="square" lIns="45720" rIns="45720" tIns="27432" bIns="27432">
-            <a:spAutoFit/>
-          </a:bodyPr>
-          <a:lstStyle/>
-          <a:p>
-            <a:pPr algn="l"/>
-            <a:r>
-              <a:rPr sz="900" b="0">
-                <a:solidFill>
-                  <a:srgbClr val="7A8A9A"/>
-                </a:solidFill>
-                <a:latin typeface="Yu Gothic"/>
-              </a:rPr>
-              <a:t>家庭医療科 勉強会 / 2026-04-09</a:t>
             </a:r>
           </a:p>
         </p:txBody>
@@ -10466,7 +10431,7 @@
         <p:spPr>
           <a:xfrm>
             <a:off x="457200" y="365760"/>
-            <a:ext cx="11430000" cy="822960"/>
+            <a:ext cx="11430000" cy="914400"/>
           </a:xfrm>
           <a:prstGeom prst="rect">
             <a:avLst/>
@@ -10481,7 +10446,7 @@
           <a:p>
             <a:pPr algn="l"/>
             <a:r>
-              <a:rPr sz="2600" b="1">
+              <a:rPr sz="3000" b="1">
                 <a:solidFill>
                   <a:srgbClr val="E89B3B"/>
                 </a:solidFill>
@@ -10500,7 +10465,42 @@
         </p:nvSpPr>
         <p:spPr>
           <a:xfrm>
-            <a:off x="11247120" y="6446520"/>
+            <a:off x="457200" y="6492240"/>
+            <a:ext cx="9601200" cy="320040"/>
+          </a:xfrm>
+          <a:prstGeom prst="rect">
+            <a:avLst/>
+          </a:prstGeom>
+          <a:noFill/>
+        </p:spPr>
+        <p:txBody>
+          <a:bodyPr wrap="square" lIns="45720" rIns="45720" tIns="27432" bIns="27432">
+            <a:spAutoFit/>
+          </a:bodyPr>
+          <a:lstStyle/>
+          <a:p>
+            <a:pPr algn="l"/>
+            <a:r>
+              <a:rPr sz="1000" b="0">
+                <a:solidFill>
+                  <a:srgbClr val="7A8A9A"/>
+                </a:solidFill>
+                <a:latin typeface="Yu Gothic"/>
+              </a:rPr>
+              <a:t>藪医者の学び / 2026-04-09 / WHOシステム思考</a:t>
+            </a:r>
+          </a:p>
+        </p:txBody>
+      </p:sp>
+      <p:sp>
+        <p:nvSpPr>
+          <p:cNvPr id="5" name="TextBox 4"/>
+          <p:cNvSpPr txBox="1"/>
+          <p:nvPr/>
+        </p:nvSpPr>
+        <p:spPr>
+          <a:xfrm>
+            <a:off x="11247120" y="6492240"/>
             <a:ext cx="914400" cy="320040"/>
           </a:xfrm>
           <a:prstGeom prst="rect">
@@ -10516,48 +10516,13 @@
           <a:p>
             <a:pPr algn="r"/>
             <a:r>
-              <a:rPr sz="900" b="0">
+              <a:rPr sz="1000" b="0">
                 <a:solidFill>
                   <a:srgbClr val="7A8A9A"/>
                 </a:solidFill>
                 <a:latin typeface="Yu Gothic"/>
               </a:rPr>
               <a:t>9 / 28</a:t>
-            </a:r>
-          </a:p>
-        </p:txBody>
-      </p:sp>
-      <p:sp>
-        <p:nvSpPr>
-          <p:cNvPr id="5" name="TextBox 4"/>
-          <p:cNvSpPr txBox="1"/>
-          <p:nvPr/>
-        </p:nvSpPr>
-        <p:spPr>
-          <a:xfrm>
-            <a:off x="457200" y="6446520"/>
-            <a:ext cx="7315200" cy="320040"/>
-          </a:xfrm>
-          <a:prstGeom prst="rect">
-            <a:avLst/>
-          </a:prstGeom>
-          <a:noFill/>
-        </p:spPr>
-        <p:txBody>
-          <a:bodyPr wrap="square" lIns="45720" rIns="45720" tIns="27432" bIns="27432">
-            <a:spAutoFit/>
-          </a:bodyPr>
-          <a:lstStyle/>
-          <a:p>
-            <a:pPr algn="l"/>
-            <a:r>
-              <a:rPr sz="900" b="0">
-                <a:solidFill>
-                  <a:srgbClr val="7A8A9A"/>
-                </a:solidFill>
-                <a:latin typeface="Yu Gothic"/>
-              </a:rPr>
-              <a:t>家庭医療科 勉強会 / 2026-04-09</a:t>
             </a:r>
           </a:p>
         </p:txBody>

</xml_diff>